<commit_message>
refresh field rep reminder workflow docs
</commit_message>
<xml_diff>
--- a/output/doc/user-flow-decks/07-field-rep-sharing-and-doctor-bulk-upload.pptx
+++ b/output/doc/user-flow-decks/07-field-rep-sharing-and-doctor-bulk-upload.pptx
@@ -13,6 +13,7 @@
     <p:sldId id="261" r:id="rId12"/>
     <p:sldId id="262" r:id="rId13"/>
     <p:sldId id="263" r:id="rId14"/>
+    <p:sldId id="264" r:id="rId15"/>
   </p:sldIdLst>
   <p:sldSz cx="12191695" cy="6858000" type="screen4x3"/>
   <p:notesSz cx="6858000" cy="9144000"/>
@@ -3213,7 +3214,7 @@
                 </a:solidFill>
                 <a:latin typeface="Aptos"/>
               </a:rPr>
-              <a:t>Document the day-to-day field-rep workflow for choosing doctors, selecting collateral, sharing through WhatsApp, and bulk-uploading doctor rosters.</a:t>
+              <a:t>Document the day-to-day field-rep workflow for choosing doctors, filtering the doctor work queue, sending collateral through WhatsApp, following up with reminders, and bulk-uploading doctor rosters.</a:t>
             </a:r>
           </a:p>
         </p:txBody>
@@ -4020,7 +4021,7 @@
                 </a:solidFill>
                 <a:latin typeface="Aptos"/>
               </a:rPr>
-              <a:t>Document the day-to-day field-rep workflow for choosing doctors, selecting collateral, sharing through WhatsApp, and bulk-uploading doctor rosters.</a:t>
+              <a:t>Document the day-to-day field-rep workflow for choosing doctors, filtering the doctor work queue, sending collateral through WhatsApp, following up with reminders, and bulk-uploading doctor rosters.</a:t>
             </a:r>
           </a:p>
         </p:txBody>
@@ -4147,7 +4148,7 @@
                 </a:solidFill>
                 <a:latin typeface="Aptos"/>
               </a:rPr>
-              <a:t>Doctors can be typed manually on the left-side form or reused from the rep's assigned doctor list on the right.</a:t>
+              <a:t>Doctors can be typed manually on the left-side form or reused from the rep's assigned doctor list on the right, where each row doubles as a quick-send shortcut.</a:t>
             </a:r>
           </a:p>
           <a:p>
@@ -4159,7 +4160,19 @@
                 </a:solidFill>
                 <a:latin typeface="Aptos"/>
               </a:rPr>
-              <a:t>Each share creates or reuses a short link and records a ShareLog entry tied to the rep, doctor, collateral, and campaign.</a:t>
+              <a:t>The right-side doctor statuses are collateral-specific and progress from `Send Message` to `Sent`, then to `Send Reminder` after six days without engagement, and finally to `Opened` once the doctor views the collateral.</a:t>
+            </a:r>
+          </a:p>
+          <a:p>
+            <a:pPr algn="l"/>
+            <a:r>
+              <a:rPr sz="1800">
+                <a:solidFill>
+                  <a:srgbClr val="102A43"/>
+                </a:solidFill>
+                <a:latin typeface="Aptos"/>
+              </a:rPr>
+              <a:t>Each quick-send action creates or reuses a short link, upserts the doctor record if needed, writes a ShareLog entry, and opens the WhatsApp deep link for that doctor and collateral.</a:t>
             </a:r>
           </a:p>
           <a:p>
@@ -4463,7 +4476,7 @@
         <p:spPr>
           <a:xfrm>
             <a:off x="749808" y="1097280"/>
-            <a:ext cx="4023360" cy="256032"/>
+            <a:ext cx="3931920" cy="4754880"/>
           </a:xfrm>
           <a:prstGeom prst="rect">
             <a:avLst/>
@@ -4471,12 +4484,19 @@
           <a:noFill/>
         </p:spPr>
         <p:txBody>
-          <a:bodyPr wrap="square" anchor="t">
+          <a:bodyPr wrap="square" lIns="0" rIns="0" tIns="0" bIns="0">
             <a:spAutoFit/>
           </a:bodyPr>
           <a:lstStyle/>
           <a:p>
-            <a:pPr algn="l"/>
+            <a:pPr algn="l">
+              <a:spcBef>
+                <a:spcPts val="0"/>
+              </a:spcBef>
+              <a:spcAft>
+                <a:spcPts val="200"/>
+              </a:spcAft>
+            </a:pPr>
             <a:r>
               <a:rPr sz="1200" b="1">
                 <a:solidFill>
@@ -4487,33 +4507,20 @@
               <a:t>User action</a:t>
             </a:r>
           </a:p>
-        </p:txBody>
-      </p:sp>
-      <p:sp>
-        <p:nvSpPr>
-          <p:cNvPr id="8" name="TextBox 7"/>
-          <p:cNvSpPr txBox="1"/>
-          <p:nvPr/>
-        </p:nvSpPr>
-        <p:spPr>
-          <a:xfrm>
-            <a:off x="749808" y="1353312"/>
-            <a:ext cx="3931920" cy="621792"/>
-          </a:xfrm>
-          <a:prstGeom prst="rect">
-            <a:avLst/>
-          </a:prstGeom>
-          <a:noFill/>
-        </p:spPr>
-        <p:txBody>
-          <a:bodyPr wrap="square" anchor="t">
-            <a:spAutoFit/>
-          </a:bodyPr>
-          <a:lstStyle/>
-          <a:p>
-            <a:pPr algn="l"/>
-            <a:r>
-              <a:rPr sz="1600" b="0">
+          <a:p>
+            <a:pPr algn="l">
+              <a:lnSpc>
+                <a:spcPct val="110000"/>
+              </a:lnSpc>
+              <a:spcBef>
+                <a:spcPts val="0"/>
+              </a:spcBef>
+              <a:spcAft>
+                <a:spcPts val="800"/>
+              </a:spcAft>
+            </a:pPr>
+            <a:r>
+              <a:rPr sz="1300">
                 <a:solidFill>
                   <a:srgbClr val="102A43"/>
                 </a:solidFill>
@@ -4522,31 +4529,15 @@
               <a:t>Use the Gmail login route for the selected campaign and land on the rep share screen.</a:t>
             </a:r>
           </a:p>
-        </p:txBody>
-      </p:sp>
-      <p:sp>
-        <p:nvSpPr>
-          <p:cNvPr id="9" name="TextBox 8"/>
-          <p:cNvSpPr txBox="1"/>
-          <p:nvPr/>
-        </p:nvSpPr>
-        <p:spPr>
-          <a:xfrm>
-            <a:off x="749808" y="2011680"/>
-            <a:ext cx="4023360" cy="256032"/>
-          </a:xfrm>
-          <a:prstGeom prst="rect">
-            <a:avLst/>
-          </a:prstGeom>
-          <a:noFill/>
-        </p:spPr>
-        <p:txBody>
-          <a:bodyPr wrap="square" anchor="t">
-            <a:spAutoFit/>
-          </a:bodyPr>
-          <a:lstStyle/>
-          <a:p>
-            <a:pPr algn="l"/>
+          <a:p>
+            <a:pPr algn="l">
+              <a:spcBef>
+                <a:spcPts val="0"/>
+              </a:spcBef>
+              <a:spcAft>
+                <a:spcPts val="200"/>
+              </a:spcAft>
+            </a:pPr>
             <a:r>
               <a:rPr sz="1200" b="1">
                 <a:solidFill>
@@ -4557,33 +4548,20 @@
               <a:t>What appears on screen</a:t>
             </a:r>
           </a:p>
-        </p:txBody>
-      </p:sp>
-      <p:sp>
-        <p:nvSpPr>
-          <p:cNvPr id="10" name="TextBox 9"/>
-          <p:cNvSpPr txBox="1"/>
-          <p:nvPr/>
-        </p:nvSpPr>
-        <p:spPr>
-          <a:xfrm>
-            <a:off x="749808" y="2267712"/>
-            <a:ext cx="3931920" cy="713232"/>
-          </a:xfrm>
-          <a:prstGeom prst="rect">
-            <a:avLst/>
-          </a:prstGeom>
-          <a:noFill/>
-        </p:spPr>
-        <p:txBody>
-          <a:bodyPr wrap="square" anchor="t">
-            <a:spAutoFit/>
-          </a:bodyPr>
-          <a:lstStyle/>
-          <a:p>
-            <a:pPr algn="l"/>
-            <a:r>
-              <a:rPr sz="1600" b="0">
+          <a:p>
+            <a:pPr algn="l">
+              <a:lnSpc>
+                <a:spcPct val="110000"/>
+              </a:lnSpc>
+              <a:spcBef>
+                <a:spcPts val="0"/>
+              </a:spcBef>
+              <a:spcAft>
+                <a:spcPts val="800"/>
+              </a:spcAft>
+            </a:pPr>
+            <a:r>
+              <a:rPr sz="1300">
                 <a:solidFill>
                   <a:srgbClr val="102A43"/>
                 </a:solidFill>
@@ -4592,31 +4570,15 @@
               <a:t>A campaign-scoped page with the rep identity, available collateral, doctor-sharing controls, and the floating support chatbot.</a:t>
             </a:r>
           </a:p>
-        </p:txBody>
-      </p:sp>
-      <p:sp>
-        <p:nvSpPr>
-          <p:cNvPr id="11" name="TextBox 10"/>
-          <p:cNvSpPr txBox="1"/>
-          <p:nvPr/>
-        </p:nvSpPr>
-        <p:spPr>
-          <a:xfrm>
-            <a:off x="749808" y="3063240"/>
-            <a:ext cx="4023360" cy="256032"/>
-          </a:xfrm>
-          <a:prstGeom prst="rect">
-            <a:avLst/>
-          </a:prstGeom>
-          <a:noFill/>
-        </p:spPr>
-        <p:txBody>
-          <a:bodyPr wrap="square" anchor="t">
-            <a:spAutoFit/>
-          </a:bodyPr>
-          <a:lstStyle/>
-          <a:p>
-            <a:pPr algn="l"/>
+          <a:p>
+            <a:pPr algn="l">
+              <a:spcBef>
+                <a:spcPts val="0"/>
+              </a:spcBef>
+              <a:spcAft>
+                <a:spcPts val="200"/>
+              </a:spcAft>
+            </a:pPr>
             <a:r>
               <a:rPr sz="1200" b="1">
                 <a:solidFill>
@@ -4627,33 +4589,20 @@
               <a:t>Why it matters</a:t>
             </a:r>
           </a:p>
-        </p:txBody>
-      </p:sp>
-      <p:sp>
-        <p:nvSpPr>
-          <p:cNvPr id="12" name="TextBox 11"/>
-          <p:cNvSpPr txBox="1"/>
-          <p:nvPr/>
-        </p:nvSpPr>
-        <p:spPr>
-          <a:xfrm>
-            <a:off x="749808" y="3319272"/>
-            <a:ext cx="3931920" cy="640080"/>
-          </a:xfrm>
-          <a:prstGeom prst="rect">
-            <a:avLst/>
-          </a:prstGeom>
-          <a:noFill/>
-        </p:spPr>
-        <p:txBody>
-          <a:bodyPr wrap="square" anchor="t">
-            <a:spAutoFit/>
-          </a:bodyPr>
-          <a:lstStyle/>
-          <a:p>
-            <a:pPr algn="l"/>
-            <a:r>
-              <a:rPr sz="1500" b="0">
+          <a:p>
+            <a:pPr algn="l">
+              <a:lnSpc>
+                <a:spcPct val="110000"/>
+              </a:lnSpc>
+              <a:spcBef>
+                <a:spcPts val="0"/>
+              </a:spcBef>
+              <a:spcAft>
+                <a:spcPts val="800"/>
+              </a:spcAft>
+            </a:pPr>
+            <a:r>
+              <a:rPr sz="1300">
                 <a:solidFill>
                   <a:srgbClr val="102A43"/>
                 </a:solidFill>
@@ -4662,31 +4611,15 @@
               <a:t>This is the operational screen reps use most frequently during campaign outreach.</a:t>
             </a:r>
           </a:p>
-        </p:txBody>
-      </p:sp>
-      <p:sp>
-        <p:nvSpPr>
-          <p:cNvPr id="13" name="TextBox 12"/>
-          <p:cNvSpPr txBox="1"/>
-          <p:nvPr/>
-        </p:nvSpPr>
-        <p:spPr>
-          <a:xfrm>
-            <a:off x="749808" y="4069080"/>
-            <a:ext cx="4023360" cy="256032"/>
-          </a:xfrm>
-          <a:prstGeom prst="rect">
-            <a:avLst/>
-          </a:prstGeom>
-          <a:noFill/>
-        </p:spPr>
-        <p:txBody>
-          <a:bodyPr wrap="square" anchor="t">
-            <a:spAutoFit/>
-          </a:bodyPr>
-          <a:lstStyle/>
-          <a:p>
-            <a:pPr algn="l"/>
+          <a:p>
+            <a:pPr algn="l">
+              <a:spcBef>
+                <a:spcPts val="0"/>
+              </a:spcBef>
+              <a:spcAft>
+                <a:spcPts val="200"/>
+              </a:spcAft>
+            </a:pPr>
             <a:r>
               <a:rPr sz="1200" b="1">
                 <a:solidFill>
@@ -4697,33 +4630,20 @@
               <a:t>Expected result</a:t>
             </a:r>
           </a:p>
-        </p:txBody>
-      </p:sp>
-      <p:sp>
-        <p:nvSpPr>
-          <p:cNvPr id="14" name="TextBox 13"/>
-          <p:cNvSpPr txBox="1"/>
-          <p:nvPr/>
-        </p:nvSpPr>
-        <p:spPr>
-          <a:xfrm>
-            <a:off x="749808" y="4325112"/>
-            <a:ext cx="3931920" cy="566928"/>
-          </a:xfrm>
-          <a:prstGeom prst="rect">
-            <a:avLst/>
-          </a:prstGeom>
-          <a:noFill/>
-        </p:spPr>
-        <p:txBody>
-          <a:bodyPr wrap="square" anchor="t">
-            <a:spAutoFit/>
-          </a:bodyPr>
-          <a:lstStyle/>
-          <a:p>
-            <a:pPr algn="l"/>
-            <a:r>
-              <a:rPr sz="1500" b="0">
+          <a:p>
+            <a:pPr algn="l">
+              <a:lnSpc>
+                <a:spcPct val="110000"/>
+              </a:lnSpc>
+              <a:spcBef>
+                <a:spcPts val="0"/>
+              </a:spcBef>
+              <a:spcAft>
+                <a:spcPts val="800"/>
+              </a:spcAft>
+            </a:pPr>
+            <a:r>
+              <a:rPr sz="1300">
                 <a:solidFill>
                   <a:srgbClr val="102A43"/>
                 </a:solidFill>
@@ -4732,31 +4652,15 @@
               <a:t>The rep can see only the active collateral that belongs to the current campaign window.</a:t>
             </a:r>
           </a:p>
-        </p:txBody>
-      </p:sp>
-      <p:sp>
-        <p:nvSpPr>
-          <p:cNvPr id="15" name="TextBox 14"/>
-          <p:cNvSpPr txBox="1"/>
-          <p:nvPr/>
-        </p:nvSpPr>
-        <p:spPr>
-          <a:xfrm>
-            <a:off x="749808" y="4965192"/>
-            <a:ext cx="4023360" cy="256032"/>
-          </a:xfrm>
-          <a:prstGeom prst="rect">
-            <a:avLst/>
-          </a:prstGeom>
-          <a:noFill/>
-        </p:spPr>
-        <p:txBody>
-          <a:bodyPr wrap="square" anchor="t">
-            <a:spAutoFit/>
-          </a:bodyPr>
-          <a:lstStyle/>
-          <a:p>
-            <a:pPr algn="l"/>
+          <a:p>
+            <a:pPr algn="l">
+              <a:spcBef>
+                <a:spcPts val="0"/>
+              </a:spcBef>
+              <a:spcAft>
+                <a:spcPts val="200"/>
+              </a:spcAft>
+            </a:pPr>
             <a:r>
               <a:rPr sz="1200" b="1">
                 <a:solidFill>
@@ -4767,33 +4671,20 @@
               <a:t>Trainer note</a:t>
             </a:r>
           </a:p>
-        </p:txBody>
-      </p:sp>
-      <p:sp>
-        <p:nvSpPr>
-          <p:cNvPr id="16" name="TextBox 15"/>
-          <p:cNvSpPr txBox="1"/>
-          <p:nvPr/>
-        </p:nvSpPr>
-        <p:spPr>
-          <a:xfrm>
-            <a:off x="749808" y="5212080"/>
-            <a:ext cx="3931920" cy="640080"/>
-          </a:xfrm>
-          <a:prstGeom prst="rect">
-            <a:avLst/>
-          </a:prstGeom>
-          <a:noFill/>
-        </p:spPr>
-        <p:txBody>
-          <a:bodyPr wrap="square" anchor="t">
-            <a:spAutoFit/>
-          </a:bodyPr>
-          <a:lstStyle/>
-          <a:p>
-            <a:pPr algn="l"/>
-            <a:r>
-              <a:rPr sz="1300" b="0">
+          <a:p>
+            <a:pPr algn="l">
+              <a:lnSpc>
+                <a:spcPct val="110000"/>
+              </a:lnSpc>
+              <a:spcBef>
+                <a:spcPts val="0"/>
+              </a:spcBef>
+              <a:spcAft>
+                <a:spcPts val="0"/>
+              </a:spcAft>
+            </a:pPr>
+            <a:r>
+              <a:rPr sz="1200">
                 <a:solidFill>
                   <a:srgbClr val="52667A"/>
                 </a:solidFill>
@@ -4806,7 +4697,7 @@
       </p:sp>
       <p:sp>
         <p:nvSpPr>
-          <p:cNvPr id="17" name="Rounded Rectangle 16"/>
+          <p:cNvPr id="8" name="Rounded Rectangle 7"/>
           <p:cNvSpPr/>
           <p:nvPr/>
         </p:nvSpPr>
@@ -4851,7 +4742,7 @@
       </p:sp>
       <p:sp>
         <p:nvSpPr>
-          <p:cNvPr id="18" name="TextBox 17"/>
+          <p:cNvPr id="9" name="TextBox 8"/>
           <p:cNvSpPr txBox="1"/>
           <p:nvPr/>
         </p:nvSpPr>
@@ -4886,7 +4777,7 @@
       </p:sp>
       <p:pic>
         <p:nvPicPr>
-          <p:cNvPr id="19" name="Picture 18" descr="fieldrep-gmail-share.png"/>
+          <p:cNvPr id="10" name="Picture 9" descr="fieldrep-gmail-share.png"/>
           <p:cNvPicPr>
             <a:picLocks noChangeAspect="1"/>
           </p:cNvPicPr>
@@ -4910,7 +4801,7 @@
       </p:pic>
       <p:sp>
         <p:nvSpPr>
-          <p:cNvPr id="20" name="TextBox 19"/>
+          <p:cNvPr id="11" name="TextBox 10"/>
           <p:cNvSpPr txBox="1"/>
           <p:nvPr/>
         </p:nvSpPr>
@@ -4945,7 +4836,7 @@
       </p:sp>
       <p:sp>
         <p:nvSpPr>
-          <p:cNvPr id="21" name="TextBox 20"/>
+          <p:cNvPr id="12" name="TextBox 11"/>
           <p:cNvSpPr txBox="1"/>
           <p:nvPr/>
         </p:nvSpPr>
@@ -5124,7 +5015,7 @@
                 </a:solidFill>
                 <a:latin typeface="Aptos"/>
               </a:rPr>
-              <a:t>Step 2: Select or confirm the doctor context</a:t>
+              <a:t>Step 2: Review the doctor queue and filter the worklist</a:t>
             </a:r>
           </a:p>
         </p:txBody>
@@ -5218,7 +5109,7 @@
         <p:spPr>
           <a:xfrm>
             <a:off x="749808" y="1097280"/>
-            <a:ext cx="4023360" cy="256032"/>
+            <a:ext cx="3931920" cy="4754880"/>
           </a:xfrm>
           <a:prstGeom prst="rect">
             <a:avLst/>
@@ -5226,12 +5117,19 @@
           <a:noFill/>
         </p:spPr>
         <p:txBody>
-          <a:bodyPr wrap="square" anchor="t">
+          <a:bodyPr wrap="square" lIns="0" rIns="0" tIns="0" bIns="0">
             <a:spAutoFit/>
           </a:bodyPr>
           <a:lstStyle/>
           <a:p>
-            <a:pPr algn="l"/>
+            <a:pPr algn="l">
+              <a:spcBef>
+                <a:spcPts val="0"/>
+              </a:spcBef>
+              <a:spcAft>
+                <a:spcPts val="200"/>
+              </a:spcAft>
+            </a:pPr>
             <a:r>
               <a:rPr sz="1200" b="1">
                 <a:solidFill>
@@ -5242,66 +5140,37 @@
               <a:t>User action</a:t>
             </a:r>
           </a:p>
-        </p:txBody>
-      </p:sp>
-      <p:sp>
-        <p:nvSpPr>
-          <p:cNvPr id="8" name="TextBox 7"/>
-          <p:cNvSpPr txBox="1"/>
-          <p:nvPr/>
-        </p:nvSpPr>
-        <p:spPr>
-          <a:xfrm>
-            <a:off x="749808" y="1353312"/>
-            <a:ext cx="3931920" cy="621792"/>
-          </a:xfrm>
-          <a:prstGeom prst="rect">
-            <a:avLst/>
-          </a:prstGeom>
-          <a:noFill/>
-        </p:spPr>
-        <p:txBody>
-          <a:bodyPr wrap="square" anchor="t">
-            <a:spAutoFit/>
-          </a:bodyPr>
-          <a:lstStyle/>
-          <a:p>
-            <a:pPr algn="l"/>
-            <a:r>
-              <a:rPr sz="1600" b="0">
+          <a:p>
+            <a:pPr algn="l">
+              <a:lnSpc>
+                <a:spcPct val="110000"/>
+              </a:lnSpc>
+              <a:spcBef>
+                <a:spcPts val="0"/>
+              </a:spcBef>
+              <a:spcAft>
+                <a:spcPts val="800"/>
+              </a:spcAft>
+            </a:pPr>
+            <a:r>
+              <a:rPr sz="1100">
                 <a:solidFill>
                   <a:srgbClr val="102A43"/>
                 </a:solidFill>
                 <a:latin typeface="Aptos"/>
               </a:rPr>
-              <a:t>Choose a doctor from the assigned doctor list or type a doctor name and WhatsApp number manually into the share form.</a:t>
-            </a:r>
-          </a:p>
-        </p:txBody>
-      </p:sp>
-      <p:sp>
-        <p:nvSpPr>
-          <p:cNvPr id="9" name="TextBox 8"/>
-          <p:cNvSpPr txBox="1"/>
-          <p:nvPr/>
-        </p:nvSpPr>
-        <p:spPr>
-          <a:xfrm>
-            <a:off x="749808" y="2011680"/>
-            <a:ext cx="4023360" cy="256032"/>
-          </a:xfrm>
-          <a:prstGeom prst="rect">
-            <a:avLst/>
-          </a:prstGeom>
-          <a:noFill/>
-        </p:spPr>
-        <p:txBody>
-          <a:bodyPr wrap="square" anchor="t">
-            <a:spAutoFit/>
-          </a:bodyPr>
-          <a:lstStyle/>
-          <a:p>
-            <a:pPr algn="l"/>
+              <a:t>Use the right-side search box, status filter, and collateral selector to find the doctor who needs action for the currently selected collateral.</a:t>
+            </a:r>
+          </a:p>
+          <a:p>
+            <a:pPr algn="l">
+              <a:spcBef>
+                <a:spcPts val="0"/>
+              </a:spcBef>
+              <a:spcAft>
+                <a:spcPts val="200"/>
+              </a:spcAft>
+            </a:pPr>
             <a:r>
               <a:rPr sz="1200" b="1">
                 <a:solidFill>
@@ -5312,66 +5181,37 @@
               <a:t>What appears on screen</a:t>
             </a:r>
           </a:p>
-        </p:txBody>
-      </p:sp>
-      <p:sp>
-        <p:nvSpPr>
-          <p:cNvPr id="10" name="TextBox 9"/>
-          <p:cNvSpPr txBox="1"/>
-          <p:nvPr/>
-        </p:nvSpPr>
-        <p:spPr>
-          <a:xfrm>
-            <a:off x="749808" y="2267712"/>
-            <a:ext cx="3931920" cy="713232"/>
-          </a:xfrm>
-          <a:prstGeom prst="rect">
-            <a:avLst/>
-          </a:prstGeom>
-          <a:noFill/>
-        </p:spPr>
-        <p:txBody>
-          <a:bodyPr wrap="square" anchor="t">
-            <a:spAutoFit/>
-          </a:bodyPr>
-          <a:lstStyle/>
-          <a:p>
-            <a:pPr algn="l"/>
-            <a:r>
-              <a:rPr sz="1600" b="0">
+          <a:p>
+            <a:pPr algn="l">
+              <a:lnSpc>
+                <a:spcPct val="110000"/>
+              </a:lnSpc>
+              <a:spcBef>
+                <a:spcPts val="0"/>
+              </a:spcBef>
+              <a:spcAft>
+                <a:spcPts val="800"/>
+              </a:spcAft>
+            </a:pPr>
+            <a:r>
+              <a:rPr sz="1100">
                 <a:solidFill>
                   <a:srgbClr val="102A43"/>
                 </a:solidFill>
                 <a:latin typeface="Aptos"/>
               </a:rPr>
-              <a:t>Manual input controls on the left and a searchable doctor list on the right, including Sent, Reminder Due, and Opened-style status cues.</a:t>
-            </a:r>
-          </a:p>
-        </p:txBody>
-      </p:sp>
-      <p:sp>
-        <p:nvSpPr>
-          <p:cNvPr id="11" name="TextBox 10"/>
-          <p:cNvSpPr txBox="1"/>
-          <p:nvPr/>
-        </p:nvSpPr>
-        <p:spPr>
-          <a:xfrm>
-            <a:off x="749808" y="3063240"/>
-            <a:ext cx="4023360" cy="256032"/>
-          </a:xfrm>
-          <a:prstGeom prst="rect">
-            <a:avLst/>
-          </a:prstGeom>
-          <a:noFill/>
-        </p:spPr>
-        <p:txBody>
-          <a:bodyPr wrap="square" anchor="t">
-            <a:spAutoFit/>
-          </a:bodyPr>
-          <a:lstStyle/>
-          <a:p>
-            <a:pPr algn="l"/>
+              <a:t>A searchable doctor roster with row-level quick-send buttons labeled `Send Message`, `Sent`, `Send Reminder`, or `Opened` depending on the latest share and engagement state.</a:t>
+            </a:r>
+          </a:p>
+          <a:p>
+            <a:pPr algn="l">
+              <a:spcBef>
+                <a:spcPts val="0"/>
+              </a:spcBef>
+              <a:spcAft>
+                <a:spcPts val="200"/>
+              </a:spcAft>
+            </a:pPr>
             <a:r>
               <a:rPr sz="1200" b="1">
                 <a:solidFill>
@@ -5382,66 +5222,37 @@
               <a:t>Why it matters</a:t>
             </a:r>
           </a:p>
-        </p:txBody>
-      </p:sp>
-      <p:sp>
-        <p:nvSpPr>
-          <p:cNvPr id="12" name="TextBox 11"/>
-          <p:cNvSpPr txBox="1"/>
-          <p:nvPr/>
-        </p:nvSpPr>
-        <p:spPr>
-          <a:xfrm>
-            <a:off x="749808" y="3319272"/>
-            <a:ext cx="3931920" cy="640080"/>
-          </a:xfrm>
-          <a:prstGeom prst="rect">
-            <a:avLst/>
-          </a:prstGeom>
-          <a:noFill/>
-        </p:spPr>
-        <p:txBody>
-          <a:bodyPr wrap="square" anchor="t">
-            <a:spAutoFit/>
-          </a:bodyPr>
-          <a:lstStyle/>
-          <a:p>
-            <a:pPr algn="l"/>
-            <a:r>
-              <a:rPr sz="1500" b="0">
+          <a:p>
+            <a:pPr algn="l">
+              <a:lnSpc>
+                <a:spcPct val="110000"/>
+              </a:lnSpc>
+              <a:spcBef>
+                <a:spcPts val="0"/>
+              </a:spcBef>
+              <a:spcAft>
+                <a:spcPts val="800"/>
+              </a:spcAft>
+            </a:pPr>
+            <a:r>
+              <a:rPr sz="1100">
                 <a:solidFill>
                   <a:srgbClr val="102A43"/>
                 </a:solidFill>
                 <a:latin typeface="Aptos"/>
               </a:rPr>
-              <a:t>Doctor identification drives the later verification step, so the number needs to be accurate.</a:t>
-            </a:r>
-          </a:p>
-        </p:txBody>
-      </p:sp>
-      <p:sp>
-        <p:nvSpPr>
-          <p:cNvPr id="13" name="TextBox 12"/>
-          <p:cNvSpPr txBox="1"/>
-          <p:nvPr/>
-        </p:nvSpPr>
-        <p:spPr>
-          <a:xfrm>
-            <a:off x="749808" y="4069080"/>
-            <a:ext cx="4023360" cy="256032"/>
-          </a:xfrm>
-          <a:prstGeom prst="rect">
-            <a:avLst/>
-          </a:prstGeom>
-          <a:noFill/>
-        </p:spPr>
-        <p:txBody>
-          <a:bodyPr wrap="square" anchor="t">
-            <a:spAutoFit/>
-          </a:bodyPr>
-          <a:lstStyle/>
-          <a:p>
-            <a:pPr algn="l"/>
+              <a:t>The right panel is the rep's live work queue. It shows who still needs a first send, who was contacted recently, who is ready for a reminder, and who already opened the collateral.</a:t>
+            </a:r>
+          </a:p>
+          <a:p>
+            <a:pPr algn="l">
+              <a:spcBef>
+                <a:spcPts val="0"/>
+              </a:spcBef>
+              <a:spcAft>
+                <a:spcPts val="200"/>
+              </a:spcAft>
+            </a:pPr>
             <a:r>
               <a:rPr sz="1200" b="1">
                 <a:solidFill>
@@ -5452,66 +5263,37 @@
               <a:t>Expected result</a:t>
             </a:r>
           </a:p>
-        </p:txBody>
-      </p:sp>
-      <p:sp>
-        <p:nvSpPr>
-          <p:cNvPr id="14" name="TextBox 13"/>
-          <p:cNvSpPr txBox="1"/>
-          <p:nvPr/>
-        </p:nvSpPr>
-        <p:spPr>
-          <a:xfrm>
-            <a:off x="749808" y="4325112"/>
-            <a:ext cx="3931920" cy="566928"/>
-          </a:xfrm>
-          <a:prstGeom prst="rect">
-            <a:avLst/>
-          </a:prstGeom>
-          <a:noFill/>
-        </p:spPr>
-        <p:txBody>
-          <a:bodyPr wrap="square" anchor="t">
-            <a:spAutoFit/>
-          </a:bodyPr>
-          <a:lstStyle/>
-          <a:p>
-            <a:pPr algn="l"/>
-            <a:r>
-              <a:rPr sz="1500" b="0">
+          <a:p>
+            <a:pPr algn="l">
+              <a:lnSpc>
+                <a:spcPct val="110000"/>
+              </a:lnSpc>
+              <a:spcBef>
+                <a:spcPts val="0"/>
+              </a:spcBef>
+              <a:spcAft>
+                <a:spcPts val="800"/>
+              </a:spcAft>
+            </a:pPr>
+            <a:r>
+              <a:rPr sz="1100">
                 <a:solidFill>
                   <a:srgbClr val="102A43"/>
                 </a:solidFill>
                 <a:latin typeface="Aptos"/>
               </a:rPr>
-              <a:t>The rep is ready to pair the right doctor with the right collateral.</a:t>
-            </a:r>
-          </a:p>
-        </p:txBody>
-      </p:sp>
-      <p:sp>
-        <p:nvSpPr>
-          <p:cNvPr id="15" name="TextBox 14"/>
-          <p:cNvSpPr txBox="1"/>
-          <p:nvPr/>
-        </p:nvSpPr>
-        <p:spPr>
-          <a:xfrm>
-            <a:off x="749808" y="4965192"/>
-            <a:ext cx="4023360" cy="256032"/>
-          </a:xfrm>
-          <a:prstGeom prst="rect">
-            <a:avLst/>
-          </a:prstGeom>
-          <a:noFill/>
-        </p:spPr>
-        <p:txBody>
-          <a:bodyPr wrap="square" anchor="t">
-            <a:spAutoFit/>
-          </a:bodyPr>
-          <a:lstStyle/>
-          <a:p>
-            <a:pPr algn="l"/>
+              <a:t>The rep can isolate the correct doctor and understand whether the next action is an initial send, a reminder, or no action at all.</a:t>
+            </a:r>
+          </a:p>
+          <a:p>
+            <a:pPr algn="l">
+              <a:spcBef>
+                <a:spcPts val="0"/>
+              </a:spcBef>
+              <a:spcAft>
+                <a:spcPts val="200"/>
+              </a:spcAft>
+            </a:pPr>
             <a:r>
               <a:rPr sz="1200" b="1">
                 <a:solidFill>
@@ -5522,46 +5304,33 @@
               <a:t>Trainer note</a:t>
             </a:r>
           </a:p>
-        </p:txBody>
-      </p:sp>
-      <p:sp>
-        <p:nvSpPr>
-          <p:cNvPr id="16" name="TextBox 15"/>
-          <p:cNvSpPr txBox="1"/>
-          <p:nvPr/>
-        </p:nvSpPr>
-        <p:spPr>
-          <a:xfrm>
-            <a:off x="749808" y="5212080"/>
-            <a:ext cx="3931920" cy="640080"/>
-          </a:xfrm>
-          <a:prstGeom prst="rect">
-            <a:avLst/>
-          </a:prstGeom>
-          <a:noFill/>
-        </p:spPr>
-        <p:txBody>
-          <a:bodyPr wrap="square" anchor="t">
-            <a:spAutoFit/>
-          </a:bodyPr>
-          <a:lstStyle/>
-          <a:p>
-            <a:pPr algn="l"/>
-            <a:r>
-              <a:rPr sz="1300" b="0">
+          <a:p>
+            <a:pPr algn="l">
+              <a:lnSpc>
+                <a:spcPct val="110000"/>
+              </a:lnSpc>
+              <a:spcBef>
+                <a:spcPts val="0"/>
+              </a:spcBef>
+              <a:spcAft>
+                <a:spcPts val="0"/>
+              </a:spcAft>
+            </a:pPr>
+            <a:r>
+              <a:rPr sz="1100">
                 <a:solidFill>
                   <a:srgbClr val="52667A"/>
                 </a:solidFill>
                 <a:latin typeface="Aptos"/>
               </a:rPr>
-              <a:t>Emphasize that the same WhatsApp number will be required again by the doctor to unlock the content.</a:t>
-            </a:r>
-          </a:p>
-        </p:txBody>
-      </p:sp>
-      <p:sp>
-        <p:nvSpPr>
-          <p:cNvPr id="17" name="Rounded Rectangle 16"/>
+              <a:t>Call out that the statuses are recalculated for the collateral currently selected on the left. Changing the collateral dropdown updates the hidden doctor-row forms and refreshes the right-side status list.</a:t>
+            </a:r>
+          </a:p>
+        </p:txBody>
+      </p:sp>
+      <p:sp>
+        <p:nvSpPr>
+          <p:cNvPr id="8" name="Rounded Rectangle 7"/>
           <p:cNvSpPr/>
           <p:nvPr/>
         </p:nvSpPr>
@@ -5606,7 +5375,7 @@
       </p:sp>
       <p:sp>
         <p:nvSpPr>
-          <p:cNvPr id="18" name="TextBox 17"/>
+          <p:cNvPr id="9" name="TextBox 8"/>
           <p:cNvSpPr txBox="1"/>
           <p:nvPr/>
         </p:nvSpPr>
@@ -5634,14 +5403,14 @@
                 </a:solidFill>
                 <a:latin typeface="Aptos"/>
               </a:rPr>
-              <a:t>Share page section showing the assigned doctor list and send-status controls.</a:t>
+              <a:t>Assigned doctor list with search, status filtering, and the live send-state buttons.</a:t>
             </a:r>
           </a:p>
         </p:txBody>
       </p:sp>
       <p:pic>
         <p:nvPicPr>
-          <p:cNvPr id="19" name="Picture 18" descr="fieldrep-gmail-share.png"/>
+          <p:cNvPr id="10" name="Picture 9" descr="fieldrep-doctor-status.png"/>
           <p:cNvPicPr>
             <a:picLocks noChangeAspect="1"/>
           </p:cNvPicPr>
@@ -5665,7 +5434,7 @@
       </p:pic>
       <p:sp>
         <p:nvSpPr>
-          <p:cNvPr id="20" name="TextBox 19"/>
+          <p:cNvPr id="11" name="TextBox 10"/>
           <p:cNvSpPr txBox="1"/>
           <p:nvPr/>
         </p:nvSpPr>
@@ -5693,14 +5462,14 @@
                 </a:solidFill>
                 <a:latin typeface="Aptos"/>
               </a:rPr>
-              <a:t>The searchable doctor roster and status-aware action buttons available during sharing.</a:t>
-            </a:r>
-          </a:p>
-        </p:txBody>
-      </p:sp>
-      <p:sp>
-        <p:nvSpPr>
-          <p:cNvPr id="21" name="TextBox 20"/>
+              <a:t>A mixed queue that shows `Send Message`, `Sent`, `Send Reminder`, and `Opened` for the currently selected collateral.</a:t>
+            </a:r>
+          </a:p>
+        </p:txBody>
+      </p:sp>
+      <p:sp>
+        <p:nvSpPr>
+          <p:cNvPr id="12" name="TextBox 11"/>
           <p:cNvSpPr txBox="1"/>
           <p:nvPr/>
         </p:nvSpPr>
@@ -5873,13 +5642,13 @@
           <a:p>
             <a:pPr algn="l"/>
             <a:r>
-              <a:rPr sz="1800" b="1">
+              <a:rPr sz="2100" b="1">
                 <a:solidFill>
                   <a:srgbClr val="FFFFFF"/>
                 </a:solidFill>
                 <a:latin typeface="Aptos"/>
               </a:rPr>
-              <a:t>Step 3: Choose collateral and launch the WhatsApp handoff</a:t>
+              <a:t>Step 3: Send the first collateral message</a:t>
             </a:r>
           </a:p>
         </p:txBody>
@@ -5973,7 +5742,7 @@
         <p:spPr>
           <a:xfrm>
             <a:off x="749808" y="1097280"/>
-            <a:ext cx="4023360" cy="256032"/>
+            <a:ext cx="3931920" cy="4754880"/>
           </a:xfrm>
           <a:prstGeom prst="rect">
             <a:avLst/>
@@ -5981,12 +5750,19 @@
           <a:noFill/>
         </p:spPr>
         <p:txBody>
-          <a:bodyPr wrap="square" anchor="t">
+          <a:bodyPr wrap="square" lIns="0" rIns="0" tIns="0" bIns="0">
             <a:spAutoFit/>
           </a:bodyPr>
           <a:lstStyle/>
           <a:p>
-            <a:pPr algn="l"/>
+            <a:pPr algn="l">
+              <a:spcBef>
+                <a:spcPts val="0"/>
+              </a:spcBef>
+              <a:spcAft>
+                <a:spcPts val="200"/>
+              </a:spcAft>
+            </a:pPr>
             <a:r>
               <a:rPr sz="1200" b="1">
                 <a:solidFill>
@@ -5997,66 +5773,37 @@
               <a:t>User action</a:t>
             </a:r>
           </a:p>
-        </p:txBody>
-      </p:sp>
-      <p:sp>
-        <p:nvSpPr>
-          <p:cNvPr id="8" name="TextBox 7"/>
-          <p:cNvSpPr txBox="1"/>
-          <p:nvPr/>
-        </p:nvSpPr>
-        <p:spPr>
-          <a:xfrm>
-            <a:off x="749808" y="1353312"/>
-            <a:ext cx="3931920" cy="621792"/>
-          </a:xfrm>
-          <a:prstGeom prst="rect">
-            <a:avLst/>
-          </a:prstGeom>
-          <a:noFill/>
-        </p:spPr>
-        <p:txBody>
-          <a:bodyPr wrap="square" anchor="t">
-            <a:spAutoFit/>
-          </a:bodyPr>
-          <a:lstStyle/>
-          <a:p>
-            <a:pPr algn="l"/>
-            <a:r>
-              <a:rPr sz="1600" b="0">
+          <a:p>
+            <a:pPr algn="l">
+              <a:lnSpc>
+                <a:spcPct val="110000"/>
+              </a:lnSpc>
+              <a:spcBef>
+                <a:spcPts val="0"/>
+              </a:spcBef>
+              <a:spcAft>
+                <a:spcPts val="800"/>
+              </a:spcAft>
+            </a:pPr>
+            <a:r>
+              <a:rPr sz="1100">
                 <a:solidFill>
                   <a:srgbClr val="102A43"/>
                 </a:solidFill>
                 <a:latin typeface="Aptos"/>
               </a:rPr>
-              <a:t>Select the collateral, submit the share form or doctor-row action, and allow the browser to open the WhatsApp deep link generated for that doctor and campaign.</a:t>
-            </a:r>
-          </a:p>
-        </p:txBody>
-      </p:sp>
-      <p:sp>
-        <p:nvSpPr>
-          <p:cNvPr id="9" name="TextBox 8"/>
-          <p:cNvSpPr txBox="1"/>
-          <p:nvPr/>
-        </p:nvSpPr>
-        <p:spPr>
-          <a:xfrm>
-            <a:off x="749808" y="2011680"/>
-            <a:ext cx="4023360" cy="256032"/>
-          </a:xfrm>
-          <a:prstGeom prst="rect">
-            <a:avLst/>
-          </a:prstGeom>
-          <a:noFill/>
-        </p:spPr>
-        <p:txBody>
-          <a:bodyPr wrap="square" anchor="t">
-            <a:spAutoFit/>
-          </a:bodyPr>
-          <a:lstStyle/>
-          <a:p>
-            <a:pPr algn="l"/>
+              <a:t>Either complete the left-side doctor form and click `Submit`, or click a doctor-row `Send Message` button to quick-send the currently selected collateral.</a:t>
+            </a:r>
+          </a:p>
+          <a:p>
+            <a:pPr algn="l">
+              <a:spcBef>
+                <a:spcPts val="0"/>
+              </a:spcBef>
+              <a:spcAft>
+                <a:spcPts val="200"/>
+              </a:spcAft>
+            </a:pPr>
             <a:r>
               <a:rPr sz="1200" b="1">
                 <a:solidFill>
@@ -6067,66 +5814,37 @@
               <a:t>What appears on screen</a:t>
             </a:r>
           </a:p>
-        </p:txBody>
-      </p:sp>
-      <p:sp>
-        <p:nvSpPr>
-          <p:cNvPr id="10" name="TextBox 9"/>
-          <p:cNvSpPr txBox="1"/>
-          <p:nvPr/>
-        </p:nvSpPr>
-        <p:spPr>
-          <a:xfrm>
-            <a:off x="749808" y="2267712"/>
-            <a:ext cx="3931920" cy="713232"/>
-          </a:xfrm>
-          <a:prstGeom prst="rect">
-            <a:avLst/>
-          </a:prstGeom>
-          <a:noFill/>
-        </p:spPr>
-        <p:txBody>
-          <a:bodyPr wrap="square" anchor="t">
-            <a:spAutoFit/>
-          </a:bodyPr>
-          <a:lstStyle/>
-          <a:p>
-            <a:pPr algn="l"/>
-            <a:r>
-              <a:rPr sz="1600" b="0">
+          <a:p>
+            <a:pPr algn="l">
+              <a:lnSpc>
+                <a:spcPct val="110000"/>
+              </a:lnSpc>
+              <a:spcBef>
+                <a:spcPts val="0"/>
+              </a:spcBef>
+              <a:spcAft>
+                <a:spcPts val="800"/>
+              </a:spcAft>
+            </a:pPr>
+            <a:r>
+              <a:rPr sz="1100">
                 <a:solidFill>
                   <a:srgbClr val="102A43"/>
                 </a:solidFill>
                 <a:latin typeface="Aptos"/>
               </a:rPr>
-              <a:t>A campaign-specific share action that uses the stored message template and short link, then hands the session off to WhatsApp.</a:t>
-            </a:r>
-          </a:p>
-        </p:txBody>
-      </p:sp>
-      <p:sp>
-        <p:nvSpPr>
-          <p:cNvPr id="11" name="TextBox 10"/>
-          <p:cNvSpPr txBox="1"/>
-          <p:nvPr/>
-        </p:nvSpPr>
-        <p:spPr>
-          <a:xfrm>
-            <a:off x="749808" y="3063240"/>
-            <a:ext cx="4023360" cy="256032"/>
-          </a:xfrm>
-          <a:prstGeom prst="rect">
-            <a:avLst/>
-          </a:prstGeom>
-          <a:noFill/>
-        </p:spPr>
-        <p:txBody>
-          <a:bodyPr wrap="square" anchor="t">
-            <a:spAutoFit/>
-          </a:bodyPr>
-          <a:lstStyle/>
-          <a:p>
-            <a:pPr algn="l"/>
+              <a:t>A submit action that resolves the doctor phone number, creates or updates the doctor record, creates or reuses the short link and ShareLog entry, and redirects into a WhatsApp deep link for the chosen doctor.</a:t>
+            </a:r>
+          </a:p>
+          <a:p>
+            <a:pPr algn="l">
+              <a:spcBef>
+                <a:spcPts val="0"/>
+              </a:spcBef>
+              <a:spcAft>
+                <a:spcPts val="200"/>
+              </a:spcAft>
+            </a:pPr>
             <a:r>
               <a:rPr sz="1200" b="1">
                 <a:solidFill>
@@ -6137,66 +5855,37 @@
               <a:t>Why it matters</a:t>
             </a:r>
           </a:p>
-        </p:txBody>
-      </p:sp>
-      <p:sp>
-        <p:nvSpPr>
-          <p:cNvPr id="12" name="TextBox 11"/>
-          <p:cNvSpPr txBox="1"/>
-          <p:nvPr/>
-        </p:nvSpPr>
-        <p:spPr>
-          <a:xfrm>
-            <a:off x="749808" y="3319272"/>
-            <a:ext cx="3931920" cy="640080"/>
-          </a:xfrm>
-          <a:prstGeom prst="rect">
-            <a:avLst/>
-          </a:prstGeom>
-          <a:noFill/>
-        </p:spPr>
-        <p:txBody>
-          <a:bodyPr wrap="square" anchor="t">
-            <a:spAutoFit/>
-          </a:bodyPr>
-          <a:lstStyle/>
-          <a:p>
-            <a:pPr algn="l"/>
-            <a:r>
-              <a:rPr sz="1500" b="0">
+          <a:p>
+            <a:pPr algn="l">
+              <a:lnSpc>
+                <a:spcPct val="110000"/>
+              </a:lnSpc>
+              <a:spcBef>
+                <a:spcPts val="0"/>
+              </a:spcBef>
+              <a:spcAft>
+                <a:spcPts val="800"/>
+              </a:spcAft>
+            </a:pPr>
+            <a:r>
+              <a:rPr sz="1100">
                 <a:solidFill>
                   <a:srgbClr val="102A43"/>
                 </a:solidFill>
                 <a:latin typeface="Aptos"/>
               </a:rPr>
-              <a:t>This is the main product outcome for the field rep: a doctor receives a trackable, campaign-linked message.</a:t>
-            </a:r>
-          </a:p>
-        </p:txBody>
-      </p:sp>
-      <p:sp>
-        <p:nvSpPr>
-          <p:cNvPr id="13" name="TextBox 12"/>
-          <p:cNvSpPr txBox="1"/>
-          <p:nvPr/>
-        </p:nvSpPr>
-        <p:spPr>
-          <a:xfrm>
-            <a:off x="749808" y="4069080"/>
-            <a:ext cx="4023360" cy="256032"/>
-          </a:xfrm>
-          <a:prstGeom prst="rect">
-            <a:avLst/>
-          </a:prstGeom>
-          <a:noFill/>
-        </p:spPr>
-        <p:txBody>
-          <a:bodyPr wrap="square" anchor="t">
-            <a:spAutoFit/>
-          </a:bodyPr>
-          <a:lstStyle/>
-          <a:p>
-            <a:pPr algn="l"/>
+              <a:t>This is the primary field-rep outcome: the doctor receives a trackable message that carries the right campaign, collateral, and rep context.</a:t>
+            </a:r>
+          </a:p>
+          <a:p>
+            <a:pPr algn="l">
+              <a:spcBef>
+                <a:spcPts val="0"/>
+              </a:spcBef>
+              <a:spcAft>
+                <a:spcPts val="200"/>
+              </a:spcAft>
+            </a:pPr>
             <a:r>
               <a:rPr sz="1200" b="1">
                 <a:solidFill>
@@ -6207,66 +5896,37 @@
               <a:t>Expected result</a:t>
             </a:r>
           </a:p>
-        </p:txBody>
-      </p:sp>
-      <p:sp>
-        <p:nvSpPr>
-          <p:cNvPr id="14" name="TextBox 13"/>
-          <p:cNvSpPr txBox="1"/>
-          <p:nvPr/>
-        </p:nvSpPr>
-        <p:spPr>
-          <a:xfrm>
-            <a:off x="749808" y="4325112"/>
-            <a:ext cx="3931920" cy="566928"/>
-          </a:xfrm>
-          <a:prstGeom prst="rect">
-            <a:avLst/>
-          </a:prstGeom>
-          <a:noFill/>
-        </p:spPr>
-        <p:txBody>
-          <a:bodyPr wrap="square" anchor="t">
-            <a:spAutoFit/>
-          </a:bodyPr>
-          <a:lstStyle/>
-          <a:p>
-            <a:pPr algn="l"/>
-            <a:r>
-              <a:rPr sz="1500" b="0">
+          <a:p>
+            <a:pPr algn="l">
+              <a:lnSpc>
+                <a:spcPct val="110000"/>
+              </a:lnSpc>
+              <a:spcBef>
+                <a:spcPts val="0"/>
+              </a:spcBef>
+              <a:spcAft>
+                <a:spcPts val="800"/>
+              </a:spcAft>
+            </a:pPr>
+            <a:r>
+              <a:rPr sz="1100">
                 <a:solidFill>
                   <a:srgbClr val="102A43"/>
                 </a:solidFill>
                 <a:latin typeface="Aptos"/>
               </a:rPr>
-              <a:t>A ShareLog is created and the doctor receives a WhatsApp message containing the short link.</a:t>
-            </a:r>
-          </a:p>
-        </p:txBody>
-      </p:sp>
-      <p:sp>
-        <p:nvSpPr>
-          <p:cNvPr id="15" name="TextBox 14"/>
-          <p:cNvSpPr txBox="1"/>
-          <p:nvPr/>
-        </p:nvSpPr>
-        <p:spPr>
-          <a:xfrm>
-            <a:off x="749808" y="4965192"/>
-            <a:ext cx="4023360" cy="256032"/>
-          </a:xfrm>
-          <a:prstGeom prst="rect">
-            <a:avLst/>
-          </a:prstGeom>
-          <a:noFill/>
-        </p:spPr>
-        <p:txBody>
-          <a:bodyPr wrap="square" anchor="t">
-            <a:spAutoFit/>
-          </a:bodyPr>
-          <a:lstStyle/>
-          <a:p>
-            <a:pPr algn="l"/>
+              <a:t>The rep launches WhatsApp with the configured collateral message and the right short link for the selected doctor.</a:t>
+            </a:r>
+          </a:p>
+          <a:p>
+            <a:pPr algn="l">
+              <a:spcBef>
+                <a:spcPts val="0"/>
+              </a:spcBef>
+              <a:spcAft>
+                <a:spcPts val="200"/>
+              </a:spcAft>
+            </a:pPr>
             <a:r>
               <a:rPr sz="1200" b="1">
                 <a:solidFill>
@@ -6277,46 +5937,33 @@
               <a:t>Trainer note</a:t>
             </a:r>
           </a:p>
-        </p:txBody>
-      </p:sp>
-      <p:sp>
-        <p:nvSpPr>
-          <p:cNvPr id="16" name="TextBox 15"/>
-          <p:cNvSpPr txBox="1"/>
-          <p:nvPr/>
-        </p:nvSpPr>
-        <p:spPr>
-          <a:xfrm>
-            <a:off x="749808" y="5212080"/>
-            <a:ext cx="3931920" cy="640080"/>
-          </a:xfrm>
-          <a:prstGeom prst="rect">
-            <a:avLst/>
-          </a:prstGeom>
-          <a:noFill/>
-        </p:spPr>
-        <p:txBody>
-          <a:bodyPr wrap="square" anchor="t">
-            <a:spAutoFit/>
-          </a:bodyPr>
-          <a:lstStyle/>
-          <a:p>
-            <a:pPr algn="l"/>
-            <a:r>
-              <a:rPr sz="1300" b="0">
+          <a:p>
+            <a:pPr algn="l">
+              <a:lnSpc>
+                <a:spcPct val="110000"/>
+              </a:lnSpc>
+              <a:spcBef>
+                <a:spcPts val="0"/>
+              </a:spcBef>
+              <a:spcAft>
+                <a:spcPts val="0"/>
+              </a:spcAft>
+            </a:pPr>
+            <a:r>
+              <a:rPr sz="1100">
                 <a:solidFill>
                   <a:srgbClr val="52667A"/>
                 </a:solidFill>
                 <a:latin typeface="Aptos"/>
               </a:rPr>
-              <a:t>During live training, you can stop after the generated message step if opening WhatsApp is not appropriate for the session.</a:t>
-            </a:r>
-          </a:p>
-        </p:txBody>
-      </p:sp>
-      <p:sp>
-        <p:nvSpPr>
-          <p:cNvPr id="17" name="Rounded Rectangle 16"/>
+              <a:t>The quick-send buttons on the right use the same POST flow as the left form. Trainers can demonstrate either path, but the doctor-row `Send Message` button is the fastest option once the roster is already loaded.</a:t>
+            </a:r>
+          </a:p>
+        </p:txBody>
+      </p:sp>
+      <p:sp>
+        <p:nvSpPr>
+          <p:cNvPr id="8" name="Rounded Rectangle 7"/>
           <p:cNvSpPr/>
           <p:nvPr/>
         </p:nvSpPr>
@@ -6361,7 +6008,7 @@
       </p:sp>
       <p:sp>
         <p:nvSpPr>
-          <p:cNvPr id="18" name="TextBox 17"/>
+          <p:cNvPr id="9" name="TextBox 8"/>
           <p:cNvSpPr txBox="1"/>
           <p:nvPr/>
         </p:nvSpPr>
@@ -6389,14 +6036,14 @@
                 </a:solidFill>
                 <a:latin typeface="Aptos"/>
               </a:rPr>
-              <a:t>Share screen immediately before launching the WhatsApp handoff.</a:t>
+              <a:t>Quick-send view filtered to doctors who still need the first collateral message.</a:t>
             </a:r>
           </a:p>
         </p:txBody>
       </p:sp>
       <p:pic>
         <p:nvPicPr>
-          <p:cNvPr id="19" name="Picture 18" descr="fieldrep-gmail-share.png"/>
+          <p:cNvPr id="10" name="Picture 9" descr="fieldrep-send-message.png"/>
           <p:cNvPicPr>
             <a:picLocks noChangeAspect="1"/>
           </p:cNvPicPr>
@@ -6420,7 +6067,7 @@
       </p:pic>
       <p:sp>
         <p:nvSpPr>
-          <p:cNvPr id="20" name="TextBox 19"/>
+          <p:cNvPr id="11" name="TextBox 10"/>
           <p:cNvSpPr txBox="1"/>
           <p:nvPr/>
         </p:nvSpPr>
@@ -6448,14 +6095,14 @@
                 </a:solidFill>
                 <a:latin typeface="Aptos"/>
               </a:rPr>
-              <a:t>The campaign-collateral selection and action button used to send the message.</a:t>
-            </a:r>
-          </a:p>
-        </p:txBody>
-      </p:sp>
-      <p:sp>
-        <p:nvSpPr>
-          <p:cNvPr id="21" name="TextBox 20"/>
+              <a:t>The active `Send Message` button that launches the first-share flow for the selected collateral.</a:t>
+            </a:r>
+          </a:p>
+        </p:txBody>
+      </p:sp>
+      <p:sp>
+        <p:nvSpPr>
+          <p:cNvPr id="12" name="TextBox 11"/>
           <p:cNvSpPr txBox="1"/>
           <p:nvPr/>
         </p:nvSpPr>
@@ -6483,7 +6130,7 @@
                 </a:solidFill>
                 <a:latin typeface="Aptos"/>
               </a:rPr>
-              <a:t>Screenshot asset: docs/product-user-flows/assets/field-rep-sharing-and-doctor-bulk-upload/fieldrep-gmail-share.png</a:t>
+              <a:t>Screenshot asset: docs/product-user-flows/assets/field-rep-sharing-and-doctor-bulk-upload/fieldrep-send-message.png</a:t>
             </a:r>
           </a:p>
         </p:txBody>
@@ -6634,7 +6281,7 @@
                 </a:solidFill>
                 <a:latin typeface="Aptos"/>
               </a:rPr>
-              <a:t>Step 4: Bulk-upload doctors when onboarding a campaign</a:t>
+              <a:t>Step 4: Send reminders and interpret follow-up states</a:t>
             </a:r>
           </a:p>
         </p:txBody>
@@ -6728,7 +6375,7 @@
         <p:spPr>
           <a:xfrm>
             <a:off x="749808" y="1097280"/>
-            <a:ext cx="4023360" cy="256032"/>
+            <a:ext cx="3931920" cy="4754880"/>
           </a:xfrm>
           <a:prstGeom prst="rect">
             <a:avLst/>
@@ -6736,12 +6383,19 @@
           <a:noFill/>
         </p:spPr>
         <p:txBody>
-          <a:bodyPr wrap="square" anchor="t">
+          <a:bodyPr wrap="square" lIns="0" rIns="0" tIns="0" bIns="0">
             <a:spAutoFit/>
           </a:bodyPr>
           <a:lstStyle/>
           <a:p>
-            <a:pPr algn="l"/>
+            <a:pPr algn="l">
+              <a:spcBef>
+                <a:spcPts val="0"/>
+              </a:spcBef>
+              <a:spcAft>
+                <a:spcPts val="200"/>
+              </a:spcAft>
+            </a:pPr>
             <a:r>
               <a:rPr sz="1200" b="1">
                 <a:solidFill>
@@ -6752,66 +6406,37 @@
               <a:t>User action</a:t>
             </a:r>
           </a:p>
-        </p:txBody>
-      </p:sp>
-      <p:sp>
-        <p:nvSpPr>
-          <p:cNvPr id="8" name="TextBox 7"/>
-          <p:cNvSpPr txBox="1"/>
-          <p:nvPr/>
-        </p:nvSpPr>
-        <p:spPr>
-          <a:xfrm>
-            <a:off x="749808" y="1353312"/>
-            <a:ext cx="3931920" cy="621792"/>
-          </a:xfrm>
-          <a:prstGeom prst="rect">
-            <a:avLst/>
-          </a:prstGeom>
-          <a:noFill/>
-        </p:spPr>
-        <p:txBody>
-          <a:bodyPr wrap="square" anchor="t">
-            <a:spAutoFit/>
-          </a:bodyPr>
-          <a:lstStyle/>
-          <a:p>
-            <a:pPr algn="l"/>
-            <a:r>
-              <a:rPr sz="1600" b="0">
+          <a:p>
+            <a:pPr algn="l">
+              <a:lnSpc>
+                <a:spcPct val="110000"/>
+              </a:lnSpc>
+              <a:spcBef>
+                <a:spcPts val="0"/>
+              </a:spcBef>
+              <a:spcAft>
+                <a:spcPts val="800"/>
+              </a:spcAft>
+            </a:pPr>
+            <a:r>
+              <a:rPr sz="1100">
                 <a:solidFill>
                   <a:srgbClr val="102A43"/>
                 </a:solidFill>
                 <a:latin typeface="Aptos"/>
               </a:rPr>
-              <a:t>Open the Doctor Bulk Upload page, download the sample CSV if needed, and upload a prepared doctor file for the campaign.</a:t>
-            </a:r>
-          </a:p>
-        </p:txBody>
-      </p:sp>
-      <p:sp>
-        <p:nvSpPr>
-          <p:cNvPr id="9" name="TextBox 8"/>
-          <p:cNvSpPr txBox="1"/>
-          <p:nvPr/>
-        </p:nvSpPr>
-        <p:spPr>
-          <a:xfrm>
-            <a:off x="749808" y="2011680"/>
-            <a:ext cx="4023360" cy="256032"/>
-          </a:xfrm>
-          <a:prstGeom prst="rect">
-            <a:avLst/>
-          </a:prstGeom>
-          <a:noFill/>
-        </p:spPr>
-        <p:txBody>
-          <a:bodyPr wrap="square" anchor="t">
-            <a:spAutoFit/>
-          </a:bodyPr>
-          <a:lstStyle/>
-          <a:p>
-            <a:pPr algn="l"/>
+              <a:t>Return to the same doctor list after a share and use the row buttons to follow up. A recent share shows `Sent`, a share older than six days without engagement changes to `Send Reminder`, and an engaged doctor shows `Opened`.</a:t>
+            </a:r>
+          </a:p>
+          <a:p>
+            <a:pPr algn="l">
+              <a:spcBef>
+                <a:spcPts val="0"/>
+              </a:spcBef>
+              <a:spcAft>
+                <a:spcPts val="200"/>
+              </a:spcAft>
+            </a:pPr>
             <a:r>
               <a:rPr sz="1200" b="1">
                 <a:solidFill>
@@ -6822,66 +6447,37 @@
               <a:t>What appears on screen</a:t>
             </a:r>
           </a:p>
-        </p:txBody>
-      </p:sp>
-      <p:sp>
-        <p:nvSpPr>
-          <p:cNvPr id="10" name="TextBox 9"/>
-          <p:cNvSpPr txBox="1"/>
-          <p:nvPr/>
-        </p:nvSpPr>
-        <p:spPr>
-          <a:xfrm>
-            <a:off x="749808" y="2267712"/>
-            <a:ext cx="3931920" cy="713232"/>
-          </a:xfrm>
-          <a:prstGeom prst="rect">
-            <a:avLst/>
-          </a:prstGeom>
-          <a:noFill/>
-        </p:spPr>
-        <p:txBody>
-          <a:bodyPr wrap="square" anchor="t">
-            <a:spAutoFit/>
-          </a:bodyPr>
-          <a:lstStyle/>
-          <a:p>
-            <a:pPr algn="l"/>
-            <a:r>
-              <a:rPr sz="1600" b="0">
+          <a:p>
+            <a:pPr algn="l">
+              <a:lnSpc>
+                <a:spcPct val="110000"/>
+              </a:lnSpc>
+              <a:spcBef>
+                <a:spcPts val="0"/>
+              </a:spcBef>
+              <a:spcAft>
+                <a:spcPts val="800"/>
+              </a:spcAft>
+            </a:pPr>
+            <a:r>
+              <a:rPr sz="1100">
                 <a:solidFill>
                   <a:srgbClr val="102A43"/>
                 </a:solidFill>
                 <a:latin typeface="Aptos"/>
               </a:rPr>
-              <a:t>A purpose-built bulk-upload form that explains the expected CSV columns and confirms successful ingestion.</a:t>
-            </a:r>
-          </a:p>
-        </p:txBody>
-      </p:sp>
-      <p:sp>
-        <p:nvSpPr>
-          <p:cNvPr id="11" name="TextBox 10"/>
-          <p:cNvSpPr txBox="1"/>
-          <p:nvPr/>
-        </p:nvSpPr>
-        <p:spPr>
-          <a:xfrm>
-            <a:off x="749808" y="3063240"/>
-            <a:ext cx="4023360" cy="256032"/>
-          </a:xfrm>
-          <a:prstGeom prst="rect">
-            <a:avLst/>
-          </a:prstGeom>
-          <a:noFill/>
-        </p:spPr>
-        <p:txBody>
-          <a:bodyPr wrap="square" anchor="t">
-            <a:spAutoFit/>
-          </a:bodyPr>
-          <a:lstStyle/>
-          <a:p>
-            <a:pPr algn="l"/>
+              <a:t>The same doctor queue, but with the follow-up state reflected directly on each doctor row. Clicking `Send Reminder` or `Sent` reuses the currently selected collateral and opens WhatsApp again; `Opened` is visible but disabled.</a:t>
+            </a:r>
+          </a:p>
+          <a:p>
+            <a:pPr algn="l">
+              <a:spcBef>
+                <a:spcPts val="0"/>
+              </a:spcBef>
+              <a:spcAft>
+                <a:spcPts val="200"/>
+              </a:spcAft>
+            </a:pPr>
             <a:r>
               <a:rPr sz="1200" b="1">
                 <a:solidFill>
@@ -6892,66 +6488,37 @@
               <a:t>Why it matters</a:t>
             </a:r>
           </a:p>
-        </p:txBody>
-      </p:sp>
-      <p:sp>
-        <p:nvSpPr>
-          <p:cNvPr id="12" name="TextBox 11"/>
-          <p:cNvSpPr txBox="1"/>
-          <p:nvPr/>
-        </p:nvSpPr>
-        <p:spPr>
-          <a:xfrm>
-            <a:off x="749808" y="3319272"/>
-            <a:ext cx="3931920" cy="640080"/>
-          </a:xfrm>
-          <a:prstGeom prst="rect">
-            <a:avLst/>
-          </a:prstGeom>
-          <a:noFill/>
-        </p:spPr>
-        <p:txBody>
-          <a:bodyPr wrap="square" anchor="t">
-            <a:spAutoFit/>
-          </a:bodyPr>
-          <a:lstStyle/>
-          <a:p>
-            <a:pPr algn="l"/>
-            <a:r>
-              <a:rPr sz="1500" b="0">
+          <a:p>
+            <a:pPr algn="l">
+              <a:lnSpc>
+                <a:spcPct val="110000"/>
+              </a:lnSpc>
+              <a:spcBef>
+                <a:spcPts val="0"/>
+              </a:spcBef>
+              <a:spcAft>
+                <a:spcPts val="800"/>
+              </a:spcAft>
+            </a:pPr>
+            <a:r>
+              <a:rPr sz="1100">
                 <a:solidFill>
                   <a:srgbClr val="102A43"/>
                 </a:solidFill>
                 <a:latin typeface="Aptos"/>
               </a:rPr>
-              <a:t>Uploading a roster up front makes manual sharing dramatically faster once the campaign goes live.</a:t>
-            </a:r>
-          </a:p>
-        </p:txBody>
-      </p:sp>
-      <p:sp>
-        <p:nvSpPr>
-          <p:cNvPr id="13" name="TextBox 12"/>
-          <p:cNvSpPr txBox="1"/>
-          <p:nvPr/>
-        </p:nvSpPr>
-        <p:spPr>
-          <a:xfrm>
-            <a:off x="749808" y="4069080"/>
-            <a:ext cx="4023360" cy="256032"/>
-          </a:xfrm>
-          <a:prstGeom prst="rect">
-            <a:avLst/>
-          </a:prstGeom>
-          <a:noFill/>
-        </p:spPr>
-        <p:txBody>
-          <a:bodyPr wrap="square" anchor="t">
-            <a:spAutoFit/>
-          </a:bodyPr>
-          <a:lstStyle/>
-          <a:p>
-            <a:pPr algn="l"/>
+              <a:t>This is how reps decide whether to resend, remind, or move on without leaving the share screen or opening a separate report.</a:t>
+            </a:r>
+          </a:p>
+          <a:p>
+            <a:pPr algn="l">
+              <a:spcBef>
+                <a:spcPts val="0"/>
+              </a:spcBef>
+              <a:spcAft>
+                <a:spcPts val="200"/>
+              </a:spcAft>
+            </a:pPr>
             <a:r>
               <a:rPr sz="1200" b="1">
                 <a:solidFill>
@@ -6962,66 +6529,37 @@
               <a:t>Expected result</a:t>
             </a:r>
           </a:p>
-        </p:txBody>
-      </p:sp>
-      <p:sp>
-        <p:nvSpPr>
-          <p:cNvPr id="14" name="TextBox 13"/>
-          <p:cNvSpPr txBox="1"/>
-          <p:nvPr/>
-        </p:nvSpPr>
-        <p:spPr>
-          <a:xfrm>
-            <a:off x="749808" y="4325112"/>
-            <a:ext cx="3931920" cy="566928"/>
-          </a:xfrm>
-          <a:prstGeom prst="rect">
-            <a:avLst/>
-          </a:prstGeom>
-          <a:noFill/>
-        </p:spPr>
-        <p:txBody>
-          <a:bodyPr wrap="square" anchor="t">
-            <a:spAutoFit/>
-          </a:bodyPr>
-          <a:lstStyle/>
-          <a:p>
-            <a:pPr algn="l"/>
-            <a:r>
-              <a:rPr sz="1500" b="0">
+          <a:p>
+            <a:pPr algn="l">
+              <a:lnSpc>
+                <a:spcPct val="110000"/>
+              </a:lnSpc>
+              <a:spcBef>
+                <a:spcPts val="0"/>
+              </a:spcBef>
+              <a:spcAft>
+                <a:spcPts val="800"/>
+              </a:spcAft>
+            </a:pPr>
+            <a:r>
+              <a:rPr sz="1100">
                 <a:solidFill>
                   <a:srgbClr val="102A43"/>
                 </a:solidFill>
                 <a:latin typeface="Aptos"/>
               </a:rPr>
-              <a:t>The rep or operator can stage multiple doctors for the same campaign in one pass.</a:t>
-            </a:r>
-          </a:p>
-        </p:txBody>
-      </p:sp>
-      <p:sp>
-        <p:nvSpPr>
-          <p:cNvPr id="15" name="TextBox 14"/>
-          <p:cNvSpPr txBox="1"/>
-          <p:nvPr/>
-        </p:nvSpPr>
-        <p:spPr>
-          <a:xfrm>
-            <a:off x="749808" y="4965192"/>
-            <a:ext cx="4023360" cy="256032"/>
-          </a:xfrm>
-          <a:prstGeom prst="rect">
-            <a:avLst/>
-          </a:prstGeom>
-          <a:noFill/>
-        </p:spPr>
-        <p:txBody>
-          <a:bodyPr wrap="square" anchor="t">
-            <a:spAutoFit/>
-          </a:bodyPr>
-          <a:lstStyle/>
-          <a:p>
-            <a:pPr algn="l"/>
+              <a:t>The rep can identify reminder-ready doctors quickly and relaunch the WhatsApp handoff for follow-up outreach when needed.</a:t>
+            </a:r>
+          </a:p>
+          <a:p>
+            <a:pPr algn="l">
+              <a:spcBef>
+                <a:spcPts val="0"/>
+              </a:spcBef>
+              <a:spcAft>
+                <a:spcPts val="200"/>
+              </a:spcAft>
+            </a:pPr>
             <a:r>
               <a:rPr sz="1200" b="1">
                 <a:solidFill>
@@ -7032,46 +6570,33 @@
               <a:t>Trainer note</a:t>
             </a:r>
           </a:p>
-        </p:txBody>
-      </p:sp>
-      <p:sp>
-        <p:nvSpPr>
-          <p:cNvPr id="16" name="TextBox 15"/>
-          <p:cNvSpPr txBox="1"/>
-          <p:nvPr/>
-        </p:nvSpPr>
-        <p:spPr>
-          <a:xfrm>
-            <a:off x="749808" y="5212080"/>
-            <a:ext cx="3931920" cy="640080"/>
-          </a:xfrm>
-          <a:prstGeom prst="rect">
-            <a:avLst/>
-          </a:prstGeom>
-          <a:noFill/>
-        </p:spPr>
-        <p:txBody>
-          <a:bodyPr wrap="square" anchor="t">
-            <a:spAutoFit/>
-          </a:bodyPr>
-          <a:lstStyle/>
-          <a:p>
-            <a:pPr algn="l"/>
-            <a:r>
-              <a:rPr sz="1300" b="0">
+          <a:p>
+            <a:pPr algn="l">
+              <a:lnSpc>
+                <a:spcPct val="110000"/>
+              </a:lnSpc>
+              <a:spcBef>
+                <a:spcPts val="0"/>
+              </a:spcBef>
+              <a:spcAft>
+                <a:spcPts val="0"/>
+              </a:spcAft>
+            </a:pPr>
+            <a:r>
+              <a:rPr sz="1100">
                 <a:solidFill>
                   <a:srgbClr val="52667A"/>
                 </a:solidFill>
                 <a:latin typeface="Aptos"/>
               </a:rPr>
-              <a:t>Use the bulk-upload step before the live sharing demo if you want the doctor list to look realistic without typing every doctor by hand.</a:t>
-            </a:r>
-          </a:p>
-        </p:txBody>
-      </p:sp>
-      <p:sp>
-        <p:nvSpPr>
-          <p:cNvPr id="17" name="Rounded Rectangle 16"/>
+              <a:t>In the current UI only `Opened` is disabled. `Sent` still posts the same share flow, so teach teams to use it deliberately as a resend shortcut while treating `Send Reminder` as the clearer follow-up state once the six-day threshold is reached.</a:t>
+            </a:r>
+          </a:p>
+        </p:txBody>
+      </p:sp>
+      <p:sp>
+        <p:nvSpPr>
+          <p:cNvPr id="8" name="Rounded Rectangle 7"/>
           <p:cNvSpPr/>
           <p:nvPr/>
         </p:nvSpPr>
@@ -7116,7 +6641,7 @@
       </p:sp>
       <p:sp>
         <p:nvSpPr>
-          <p:cNvPr id="18" name="TextBox 17"/>
+          <p:cNvPr id="9" name="TextBox 8"/>
           <p:cNvSpPr txBox="1"/>
           <p:nvPr/>
         </p:nvSpPr>
@@ -7144,14 +6669,14 @@
                 </a:solidFill>
                 <a:latin typeface="Aptos"/>
               </a:rPr>
-              <a:t>Doctor bulk-upload screen with sample CSV guidance.</a:t>
+              <a:t>Reminder-due doctor view showing the follow-up button for a previously shared collateral.</a:t>
             </a:r>
           </a:p>
         </p:txBody>
       </p:sp>
       <p:pic>
         <p:nvPicPr>
-          <p:cNvPr id="19" name="Picture 18" descr="doctor-bulk-upload.png"/>
+          <p:cNvPr id="10" name="Picture 9" descr="fieldrep-send-reminder.png"/>
           <p:cNvPicPr>
             <a:picLocks noChangeAspect="1"/>
           </p:cNvPicPr>
@@ -7175,7 +6700,7 @@
       </p:pic>
       <p:sp>
         <p:nvSpPr>
-          <p:cNvPr id="20" name="TextBox 19"/>
+          <p:cNvPr id="11" name="TextBox 10"/>
           <p:cNvSpPr txBox="1"/>
           <p:nvPr/>
         </p:nvSpPr>
@@ -7203,14 +6728,14 @@
                 </a:solidFill>
                 <a:latin typeface="Aptos"/>
               </a:rPr>
-              <a:t>The upload field and the expected column list.</a:t>
-            </a:r>
-          </a:p>
-        </p:txBody>
-      </p:sp>
-      <p:sp>
-        <p:nvSpPr>
-          <p:cNvPr id="21" name="TextBox 20"/>
+              <a:t>The `Send Reminder` action available after the share ages past the six-day threshold without a doctor view.</a:t>
+            </a:r>
+          </a:p>
+        </p:txBody>
+      </p:sp>
+      <p:sp>
+        <p:nvSpPr>
+          <p:cNvPr id="12" name="TextBox 11"/>
           <p:cNvSpPr txBox="1"/>
           <p:nvPr/>
         </p:nvSpPr>
@@ -7238,7 +6763,7 @@
                 </a:solidFill>
                 <a:latin typeface="Aptos"/>
               </a:rPr>
-              <a:t>Screenshot asset: docs/product-user-flows/assets/field-rep-sharing-and-doctor-bulk-upload/doctor-bulk-upload.png</a:t>
+              <a:t>Screenshot asset: docs/product-user-flows/assets/field-rep-sharing-and-doctor-bulk-upload/fieldrep-send-reminder.png</a:t>
             </a:r>
           </a:p>
         </p:txBody>
@@ -7383,13 +6908,13 @@
           <a:p>
             <a:pPr algn="l"/>
             <a:r>
-              <a:rPr sz="2600" b="1">
+              <a:rPr sz="1800" b="1">
                 <a:solidFill>
                   <a:srgbClr val="FFFFFF"/>
                 </a:solidFill>
                 <a:latin typeface="Aptos"/>
               </a:rPr>
-              <a:t>Trainer Tips</a:t>
+              <a:t>Step 5: Bulk-upload doctors when onboarding a campaign</a:t>
             </a:r>
           </a:p>
         </p:txBody>
@@ -7437,8 +6962,8 @@
         </p:nvSpPr>
         <p:spPr>
           <a:xfrm>
-            <a:off x="640080" y="1188720"/>
-            <a:ext cx="10972800" cy="4389120"/>
+            <a:off x="502920" y="914400"/>
+            <a:ext cx="4572000" cy="5212080"/>
           </a:xfrm>
           <a:prstGeom prst="roundRect">
             <a:avLst/>
@@ -7482,8 +7007,281 @@
         </p:nvSpPr>
         <p:spPr>
           <a:xfrm>
-            <a:off x="914400" y="1463040"/>
-            <a:ext cx="2286000" cy="274320"/>
+            <a:off x="749808" y="1097280"/>
+            <a:ext cx="3931920" cy="4754880"/>
+          </a:xfrm>
+          <a:prstGeom prst="rect">
+            <a:avLst/>
+          </a:prstGeom>
+          <a:noFill/>
+        </p:spPr>
+        <p:txBody>
+          <a:bodyPr wrap="square" lIns="0" rIns="0" tIns="0" bIns="0">
+            <a:spAutoFit/>
+          </a:bodyPr>
+          <a:lstStyle/>
+          <a:p>
+            <a:pPr algn="l">
+              <a:spcBef>
+                <a:spcPts val="0"/>
+              </a:spcBef>
+              <a:spcAft>
+                <a:spcPts val="200"/>
+              </a:spcAft>
+            </a:pPr>
+            <a:r>
+              <a:rPr sz="1200" b="1">
+                <a:solidFill>
+                  <a:srgbClr val="14B8A6"/>
+                </a:solidFill>
+                <a:latin typeface="Aptos"/>
+              </a:rPr>
+              <a:t>User action</a:t>
+            </a:r>
+          </a:p>
+          <a:p>
+            <a:pPr algn="l">
+              <a:lnSpc>
+                <a:spcPct val="110000"/>
+              </a:lnSpc>
+              <a:spcBef>
+                <a:spcPts val="0"/>
+              </a:spcBef>
+              <a:spcAft>
+                <a:spcPts val="800"/>
+              </a:spcAft>
+            </a:pPr>
+            <a:r>
+              <a:rPr sz="1300">
+                <a:solidFill>
+                  <a:srgbClr val="102A43"/>
+                </a:solidFill>
+                <a:latin typeface="Aptos"/>
+              </a:rPr>
+              <a:t>Open the Doctor Bulk Upload page, download the sample CSV if needed, and upload a prepared doctor file for the campaign.</a:t>
+            </a:r>
+          </a:p>
+          <a:p>
+            <a:pPr algn="l">
+              <a:spcBef>
+                <a:spcPts val="0"/>
+              </a:spcBef>
+              <a:spcAft>
+                <a:spcPts val="200"/>
+              </a:spcAft>
+            </a:pPr>
+            <a:r>
+              <a:rPr sz="1200" b="1">
+                <a:solidFill>
+                  <a:srgbClr val="14B8A6"/>
+                </a:solidFill>
+                <a:latin typeface="Aptos"/>
+              </a:rPr>
+              <a:t>What appears on screen</a:t>
+            </a:r>
+          </a:p>
+          <a:p>
+            <a:pPr algn="l">
+              <a:lnSpc>
+                <a:spcPct val="110000"/>
+              </a:lnSpc>
+              <a:spcBef>
+                <a:spcPts val="0"/>
+              </a:spcBef>
+              <a:spcAft>
+                <a:spcPts val="800"/>
+              </a:spcAft>
+            </a:pPr>
+            <a:r>
+              <a:rPr sz="1300">
+                <a:solidFill>
+                  <a:srgbClr val="102A43"/>
+                </a:solidFill>
+                <a:latin typeface="Aptos"/>
+              </a:rPr>
+              <a:t>A purpose-built bulk-upload form that explains the expected CSV columns and confirms successful ingestion.</a:t>
+            </a:r>
+          </a:p>
+          <a:p>
+            <a:pPr algn="l">
+              <a:spcBef>
+                <a:spcPts val="0"/>
+              </a:spcBef>
+              <a:spcAft>
+                <a:spcPts val="200"/>
+              </a:spcAft>
+            </a:pPr>
+            <a:r>
+              <a:rPr sz="1200" b="1">
+                <a:solidFill>
+                  <a:srgbClr val="14B8A6"/>
+                </a:solidFill>
+                <a:latin typeface="Aptos"/>
+              </a:rPr>
+              <a:t>Why it matters</a:t>
+            </a:r>
+          </a:p>
+          <a:p>
+            <a:pPr algn="l">
+              <a:lnSpc>
+                <a:spcPct val="110000"/>
+              </a:lnSpc>
+              <a:spcBef>
+                <a:spcPts val="0"/>
+              </a:spcBef>
+              <a:spcAft>
+                <a:spcPts val="800"/>
+              </a:spcAft>
+            </a:pPr>
+            <a:r>
+              <a:rPr sz="1300">
+                <a:solidFill>
+                  <a:srgbClr val="102A43"/>
+                </a:solidFill>
+                <a:latin typeface="Aptos"/>
+              </a:rPr>
+              <a:t>Uploading a roster up front makes manual sharing dramatically faster once the campaign goes live.</a:t>
+            </a:r>
+          </a:p>
+          <a:p>
+            <a:pPr algn="l">
+              <a:spcBef>
+                <a:spcPts val="0"/>
+              </a:spcBef>
+              <a:spcAft>
+                <a:spcPts val="200"/>
+              </a:spcAft>
+            </a:pPr>
+            <a:r>
+              <a:rPr sz="1200" b="1">
+                <a:solidFill>
+                  <a:srgbClr val="14B8A6"/>
+                </a:solidFill>
+                <a:latin typeface="Aptos"/>
+              </a:rPr>
+              <a:t>Expected result</a:t>
+            </a:r>
+          </a:p>
+          <a:p>
+            <a:pPr algn="l">
+              <a:lnSpc>
+                <a:spcPct val="110000"/>
+              </a:lnSpc>
+              <a:spcBef>
+                <a:spcPts val="0"/>
+              </a:spcBef>
+              <a:spcAft>
+                <a:spcPts val="800"/>
+              </a:spcAft>
+            </a:pPr>
+            <a:r>
+              <a:rPr sz="1300">
+                <a:solidFill>
+                  <a:srgbClr val="102A43"/>
+                </a:solidFill>
+                <a:latin typeface="Aptos"/>
+              </a:rPr>
+              <a:t>The rep or operator can stage multiple doctors for the same campaign in one pass.</a:t>
+            </a:r>
+          </a:p>
+          <a:p>
+            <a:pPr algn="l">
+              <a:spcBef>
+                <a:spcPts val="0"/>
+              </a:spcBef>
+              <a:spcAft>
+                <a:spcPts val="200"/>
+              </a:spcAft>
+            </a:pPr>
+            <a:r>
+              <a:rPr sz="1200" b="1">
+                <a:solidFill>
+                  <a:srgbClr val="F97316"/>
+                </a:solidFill>
+                <a:latin typeface="Aptos"/>
+              </a:rPr>
+              <a:t>Trainer note</a:t>
+            </a:r>
+          </a:p>
+          <a:p>
+            <a:pPr algn="l">
+              <a:lnSpc>
+                <a:spcPct val="110000"/>
+              </a:lnSpc>
+              <a:spcBef>
+                <a:spcPts val="0"/>
+              </a:spcBef>
+              <a:spcAft>
+                <a:spcPts val="0"/>
+              </a:spcAft>
+            </a:pPr>
+            <a:r>
+              <a:rPr sz="1200">
+                <a:solidFill>
+                  <a:srgbClr val="52667A"/>
+                </a:solidFill>
+                <a:latin typeface="Aptos"/>
+              </a:rPr>
+              <a:t>Use the bulk-upload step before the live sharing demo if you want the doctor list to look realistic without typing every doctor by hand.</a:t>
+            </a:r>
+          </a:p>
+        </p:txBody>
+      </p:sp>
+      <p:sp>
+        <p:nvSpPr>
+          <p:cNvPr id="8" name="Rounded Rectangle 7"/>
+          <p:cNvSpPr/>
+          <p:nvPr/>
+        </p:nvSpPr>
+        <p:spPr>
+          <a:xfrm>
+            <a:off x="5303520" y="914400"/>
+            <a:ext cx="6355080" cy="5212080"/>
+          </a:xfrm>
+          <a:prstGeom prst="roundRect">
+            <a:avLst/>
+          </a:prstGeom>
+          <a:solidFill>
+            <a:srgbClr val="FFFFFF"/>
+          </a:solidFill>
+          <a:ln>
+            <a:solidFill>
+              <a:srgbClr val="E2E8F0"/>
+            </a:solidFill>
+          </a:ln>
+        </p:spPr>
+        <p:style>
+          <a:lnRef idx="1">
+            <a:schemeClr val="accent1"/>
+          </a:lnRef>
+          <a:fillRef idx="3">
+            <a:schemeClr val="accent1"/>
+          </a:fillRef>
+          <a:effectRef idx="2">
+            <a:schemeClr val="accent1"/>
+          </a:effectRef>
+          <a:fontRef idx="minor">
+            <a:schemeClr val="lt1"/>
+          </a:fontRef>
+        </p:style>
+        <p:txBody>
+          <a:bodyPr rtlCol="0" anchor="ctr"/>
+          <a:lstStyle/>
+          <a:p>
+            <a:pPr algn="ctr"/>
+          </a:p>
+        </p:txBody>
+      </p:sp>
+      <p:sp>
+        <p:nvSpPr>
+          <p:cNvPr id="9" name="TextBox 8"/>
+          <p:cNvSpPr txBox="1"/>
+          <p:nvPr/>
+        </p:nvSpPr>
+        <p:spPr>
+          <a:xfrm>
+            <a:off x="5577840" y="1097280"/>
+            <a:ext cx="5669280" cy="228600"/>
           </a:xfrm>
           <a:prstGeom prst="rect">
             <a:avLst/>
@@ -7498,74 +7296,51 @@
           <a:p>
             <a:pPr algn="l"/>
             <a:r>
-              <a:rPr sz="1400" b="1">
+              <a:rPr sz="1300" b="1">
                 <a:solidFill>
                   <a:srgbClr val="14B8A6"/>
                 </a:solidFill>
                 <a:latin typeface="Aptos"/>
               </a:rPr>
-              <a:t>Facilitation notes</a:t>
-            </a:r>
-          </a:p>
-        </p:txBody>
-      </p:sp>
-      <p:sp>
-        <p:nvSpPr>
-          <p:cNvPr id="8" name="TextBox 7"/>
+              <a:t>Doctor bulk-upload screen with sample CSV guidance.</a:t>
+            </a:r>
+          </a:p>
+        </p:txBody>
+      </p:sp>
+      <p:pic>
+        <p:nvPicPr>
+          <p:cNvPr id="10" name="Picture 9" descr="doctor-bulk-upload.png"/>
+          <p:cNvPicPr>
+            <a:picLocks noChangeAspect="1"/>
+          </p:cNvPicPr>
+          <p:nvPr/>
+        </p:nvPicPr>
+        <p:blipFill>
+          <a:blip r:embed="rId2"/>
+          <a:stretch>
+            <a:fillRect/>
+          </a:stretch>
+        </p:blipFill>
+        <p:spPr>
+          <a:xfrm>
+            <a:off x="5559552" y="1417320"/>
+            <a:ext cx="5806440" cy="4160520"/>
+          </a:xfrm>
+          <a:prstGeom prst="rect">
+            <a:avLst/>
+          </a:prstGeom>
+        </p:spPr>
+      </p:pic>
+      <p:sp>
+        <p:nvSpPr>
+          <p:cNvPr id="11" name="TextBox 10"/>
           <p:cNvSpPr txBox="1"/>
           <p:nvPr/>
         </p:nvSpPr>
         <p:spPr>
           <a:xfrm>
-            <a:off x="914400" y="1828800"/>
-            <a:ext cx="10241280" cy="3017520"/>
-          </a:xfrm>
-          <a:prstGeom prst="rect">
-            <a:avLst/>
-          </a:prstGeom>
-          <a:noFill/>
-        </p:spPr>
-        <p:txBody>
-          <a:bodyPr wrap="square">
-            <a:spAutoFit/>
-          </a:bodyPr>
-          <a:lstStyle/>
-          <a:p>
-            <a:pPr algn="l"/>
-            <a:r>
-              <a:rPr sz="2200">
-                <a:solidFill>
-                  <a:srgbClr val="102A43"/>
-                </a:solidFill>
-                <a:latin typeface="Aptos"/>
-              </a:rPr>
-              <a:t>Use a real-looking doctor list before your demo so the share screen feels grounded.</a:t>
-            </a:r>
-          </a:p>
-          <a:p>
-            <a:pPr algn="l"/>
-            <a:r>
-              <a:rPr sz="2200">
-                <a:solidFill>
-                  <a:srgbClr val="102A43"/>
-                </a:solidFill>
-                <a:latin typeface="Aptos"/>
-              </a:rPr>
-              <a:t>Warn the audience that the product opens a WhatsApp deep link, which may leave the browser context during a live session.</a:t>
-            </a:r>
-          </a:p>
-        </p:txBody>
-      </p:sp>
-      <p:sp>
-        <p:nvSpPr>
-          <p:cNvPr id="9" name="TextBox 8"/>
-          <p:cNvSpPr txBox="1"/>
-          <p:nvPr/>
-        </p:nvSpPr>
-        <p:spPr>
-          <a:xfrm>
-            <a:off x="914400" y="5257800"/>
-            <a:ext cx="10058400" cy="365760"/>
+            <a:off x="5577840" y="5669280"/>
+            <a:ext cx="5623560" cy="320040"/>
           </a:xfrm>
           <a:prstGeom prst="rect">
             <a:avLst/>
@@ -7586,14 +7361,14 @@
                 </a:solidFill>
                 <a:latin typeface="Aptos"/>
               </a:rPr>
-              <a:t>Related documents: docs/product-user-flows/08-doctor-verification-and-collateral-consumption.md, backend/sharing_management/views.py, backend/sharing_management/templates/sharing_management/fieldrep_gmail_share_collateral.html</a:t>
-            </a:r>
-          </a:p>
-        </p:txBody>
-      </p:sp>
-      <p:sp>
-        <p:nvSpPr>
-          <p:cNvPr id="10" name="TextBox 9"/>
+              <a:t>The upload field and the expected column list.</a:t>
+            </a:r>
+          </a:p>
+        </p:txBody>
+      </p:sp>
+      <p:sp>
+        <p:nvSpPr>
+          <p:cNvPr id="12" name="TextBox 11"/>
           <p:cNvSpPr txBox="1"/>
           <p:nvPr/>
         </p:nvSpPr>
@@ -7621,7 +7396,7 @@
                 </a:solidFill>
                 <a:latin typeface="Aptos"/>
               </a:rPr>
-              <a:t>Validated against the Gmail/manual share flow and doctor bulk-upload page on 2026-04-23.</a:t>
+              <a:t>Screenshot asset: docs/product-user-flows/assets/field-rep-sharing-and-doctor-bulk-upload/doctor-bulk-upload.png</a:t>
             </a:r>
           </a:p>
         </p:txBody>
@@ -7635,6 +7410,413 @@
 </file>
 
 <file path=ppt/slides/slide8.xml><?xml version="1.0" encoding="utf-8"?>
+<p:sld xmlns:a="http://schemas.openxmlformats.org/drawingml/2006/main" xmlns:p="http://schemas.openxmlformats.org/presentationml/2006/main" xmlns:r="http://schemas.openxmlformats.org/officeDocument/2006/relationships">
+  <p:cSld>
+    <p:bg>
+      <p:bgPr>
+        <a:solidFill>
+          <a:srgbClr val="F7F8FA"/>
+        </a:solidFill>
+        <a:effectLst/>
+      </p:bgPr>
+    </p:bg>
+    <p:spTree>
+      <p:nvGrpSpPr>
+        <p:cNvPr id="1" name=""/>
+        <p:cNvGrpSpPr/>
+        <p:nvPr/>
+      </p:nvGrpSpPr>
+      <p:grpSpPr/>
+      <p:sp>
+        <p:nvSpPr>
+          <p:cNvPr id="2" name="Rectangle 1"/>
+          <p:cNvSpPr/>
+          <p:nvPr/>
+        </p:nvSpPr>
+        <p:spPr>
+          <a:xfrm>
+            <a:off x="0" y="0"/>
+            <a:ext cx="12191695" cy="594360"/>
+          </a:xfrm>
+          <a:prstGeom prst="rect">
+            <a:avLst/>
+          </a:prstGeom>
+          <a:solidFill>
+            <a:srgbClr val="0B1F33"/>
+          </a:solidFill>
+          <a:ln>
+            <a:solidFill>
+              <a:srgbClr val="0B1F33"/>
+            </a:solidFill>
+          </a:ln>
+        </p:spPr>
+        <p:style>
+          <a:lnRef idx="1">
+            <a:schemeClr val="accent1"/>
+          </a:lnRef>
+          <a:fillRef idx="3">
+            <a:schemeClr val="accent1"/>
+          </a:fillRef>
+          <a:effectRef idx="2">
+            <a:schemeClr val="accent1"/>
+          </a:effectRef>
+          <a:fontRef idx="minor">
+            <a:schemeClr val="lt1"/>
+          </a:fontRef>
+        </p:style>
+        <p:txBody>
+          <a:bodyPr rtlCol="0" anchor="ctr"/>
+          <a:lstStyle/>
+          <a:p>
+            <a:pPr algn="ctr"/>
+          </a:p>
+        </p:txBody>
+      </p:sp>
+      <p:sp>
+        <p:nvSpPr>
+          <p:cNvPr id="3" name="Rectangle 2"/>
+          <p:cNvSpPr/>
+          <p:nvPr/>
+        </p:nvSpPr>
+        <p:spPr>
+          <a:xfrm>
+            <a:off x="0" y="594360"/>
+            <a:ext cx="1234440" cy="109728"/>
+          </a:xfrm>
+          <a:prstGeom prst="rect">
+            <a:avLst/>
+          </a:prstGeom>
+          <a:solidFill>
+            <a:srgbClr val="F97316"/>
+          </a:solidFill>
+          <a:ln>
+            <a:solidFill>
+              <a:srgbClr val="F97316"/>
+            </a:solidFill>
+          </a:ln>
+        </p:spPr>
+        <p:style>
+          <a:lnRef idx="1">
+            <a:schemeClr val="accent1"/>
+          </a:lnRef>
+          <a:fillRef idx="3">
+            <a:schemeClr val="accent1"/>
+          </a:fillRef>
+          <a:effectRef idx="2">
+            <a:schemeClr val="accent1"/>
+          </a:effectRef>
+          <a:fontRef idx="minor">
+            <a:schemeClr val="lt1"/>
+          </a:fontRef>
+        </p:style>
+        <p:txBody>
+          <a:bodyPr rtlCol="0" anchor="ctr"/>
+          <a:lstStyle/>
+          <a:p>
+            <a:pPr algn="ctr"/>
+          </a:p>
+        </p:txBody>
+      </p:sp>
+      <p:sp>
+        <p:nvSpPr>
+          <p:cNvPr id="4" name="TextBox 3"/>
+          <p:cNvSpPr txBox="1"/>
+          <p:nvPr/>
+        </p:nvSpPr>
+        <p:spPr>
+          <a:xfrm>
+            <a:off x="502920" y="109728"/>
+            <a:ext cx="9326880" cy="292608"/>
+          </a:xfrm>
+          <a:prstGeom prst="rect">
+            <a:avLst/>
+          </a:prstGeom>
+          <a:noFill/>
+        </p:spPr>
+        <p:txBody>
+          <a:bodyPr wrap="square" anchor="t">
+            <a:spAutoFit/>
+          </a:bodyPr>
+          <a:lstStyle/>
+          <a:p>
+            <a:pPr algn="l"/>
+            <a:r>
+              <a:rPr sz="2600" b="1">
+                <a:solidFill>
+                  <a:srgbClr val="FFFFFF"/>
+                </a:solidFill>
+                <a:latin typeface="Aptos"/>
+              </a:rPr>
+              <a:t>Trainer Tips</a:t>
+            </a:r>
+          </a:p>
+        </p:txBody>
+      </p:sp>
+      <p:sp>
+        <p:nvSpPr>
+          <p:cNvPr id="5" name="TextBox 4"/>
+          <p:cNvSpPr txBox="1"/>
+          <p:nvPr/>
+        </p:nvSpPr>
+        <p:spPr>
+          <a:xfrm>
+            <a:off x="8503920" y="182880"/>
+            <a:ext cx="3108960" cy="228600"/>
+          </a:xfrm>
+          <a:prstGeom prst="rect">
+            <a:avLst/>
+          </a:prstGeom>
+          <a:noFill/>
+        </p:spPr>
+        <p:txBody>
+          <a:bodyPr wrap="square" anchor="t">
+            <a:spAutoFit/>
+          </a:bodyPr>
+          <a:lstStyle/>
+          <a:p>
+            <a:pPr algn="r"/>
+            <a:r>
+              <a:rPr sz="1100" b="0">
+                <a:solidFill>
+                  <a:srgbClr val="FFFFFF"/>
+                </a:solidFill>
+                <a:latin typeface="Aptos"/>
+              </a:rPr>
+              <a:t>Field Rep Sharing and Doctor Bulk Upload</a:t>
+            </a:r>
+          </a:p>
+        </p:txBody>
+      </p:sp>
+      <p:sp>
+        <p:nvSpPr>
+          <p:cNvPr id="6" name="Rounded Rectangle 5"/>
+          <p:cNvSpPr/>
+          <p:nvPr/>
+        </p:nvSpPr>
+        <p:spPr>
+          <a:xfrm>
+            <a:off x="640080" y="1188720"/>
+            <a:ext cx="10972800" cy="4389120"/>
+          </a:xfrm>
+          <a:prstGeom prst="roundRect">
+            <a:avLst/>
+          </a:prstGeom>
+          <a:solidFill>
+            <a:srgbClr val="FFFFFF"/>
+          </a:solidFill>
+          <a:ln>
+            <a:solidFill>
+              <a:srgbClr val="E2E8F0"/>
+            </a:solidFill>
+          </a:ln>
+        </p:spPr>
+        <p:style>
+          <a:lnRef idx="1">
+            <a:schemeClr val="accent1"/>
+          </a:lnRef>
+          <a:fillRef idx="3">
+            <a:schemeClr val="accent1"/>
+          </a:fillRef>
+          <a:effectRef idx="2">
+            <a:schemeClr val="accent1"/>
+          </a:effectRef>
+          <a:fontRef idx="minor">
+            <a:schemeClr val="lt1"/>
+          </a:fontRef>
+        </p:style>
+        <p:txBody>
+          <a:bodyPr rtlCol="0" anchor="ctr"/>
+          <a:lstStyle/>
+          <a:p>
+            <a:pPr algn="ctr"/>
+          </a:p>
+        </p:txBody>
+      </p:sp>
+      <p:sp>
+        <p:nvSpPr>
+          <p:cNvPr id="7" name="TextBox 6"/>
+          <p:cNvSpPr txBox="1"/>
+          <p:nvPr/>
+        </p:nvSpPr>
+        <p:spPr>
+          <a:xfrm>
+            <a:off x="914400" y="1463040"/>
+            <a:ext cx="2286000" cy="274320"/>
+          </a:xfrm>
+          <a:prstGeom prst="rect">
+            <a:avLst/>
+          </a:prstGeom>
+          <a:noFill/>
+        </p:spPr>
+        <p:txBody>
+          <a:bodyPr wrap="square" anchor="t">
+            <a:spAutoFit/>
+          </a:bodyPr>
+          <a:lstStyle/>
+          <a:p>
+            <a:pPr algn="l"/>
+            <a:r>
+              <a:rPr sz="1400" b="1">
+                <a:solidFill>
+                  <a:srgbClr val="14B8A6"/>
+                </a:solidFill>
+                <a:latin typeface="Aptos"/>
+              </a:rPr>
+              <a:t>Facilitation notes</a:t>
+            </a:r>
+          </a:p>
+        </p:txBody>
+      </p:sp>
+      <p:sp>
+        <p:nvSpPr>
+          <p:cNvPr id="8" name="TextBox 7"/>
+          <p:cNvSpPr txBox="1"/>
+          <p:nvPr/>
+        </p:nvSpPr>
+        <p:spPr>
+          <a:xfrm>
+            <a:off x="914400" y="1828800"/>
+            <a:ext cx="10241280" cy="3017520"/>
+          </a:xfrm>
+          <a:prstGeom prst="rect">
+            <a:avLst/>
+          </a:prstGeom>
+          <a:noFill/>
+        </p:spPr>
+        <p:txBody>
+          <a:bodyPr wrap="square">
+            <a:spAutoFit/>
+          </a:bodyPr>
+          <a:lstStyle/>
+          <a:p>
+            <a:pPr algn="l"/>
+            <a:r>
+              <a:rPr sz="2200">
+                <a:solidFill>
+                  <a:srgbClr val="102A43"/>
+                </a:solidFill>
+                <a:latin typeface="Aptos"/>
+              </a:rPr>
+              <a:t>Use a real-looking doctor list before your demo so the share screen feels grounded.</a:t>
+            </a:r>
+          </a:p>
+          <a:p>
+            <a:pPr algn="l"/>
+            <a:r>
+              <a:rPr sz="2200">
+                <a:solidFill>
+                  <a:srgbClr val="102A43"/>
+                </a:solidFill>
+                <a:latin typeface="Aptos"/>
+              </a:rPr>
+              <a:t>Remind trainees that changing the collateral dropdown recalculates the right-side statuses for that collateral and keeps the quick-send forms in sync.</a:t>
+            </a:r>
+          </a:p>
+          <a:p>
+            <a:pPr algn="l"/>
+            <a:r>
+              <a:rPr sz="2200">
+                <a:solidFill>
+                  <a:srgbClr val="102A43"/>
+                </a:solidFill>
+                <a:latin typeface="Aptos"/>
+              </a:rPr>
+              <a:t>Only `Opened` is disabled in the current template; `Sent` and `Send Reminder` are both actionable quick-send buttons.</a:t>
+            </a:r>
+          </a:p>
+          <a:p>
+            <a:pPr algn="l"/>
+            <a:r>
+              <a:rPr sz="2200">
+                <a:solidFill>
+                  <a:srgbClr val="102A43"/>
+                </a:solidFill>
+                <a:latin typeface="Aptos"/>
+              </a:rPr>
+              <a:t>Warn the audience that the product opens a WhatsApp deep link, which may leave the browser context during a live session.</a:t>
+            </a:r>
+          </a:p>
+        </p:txBody>
+      </p:sp>
+      <p:sp>
+        <p:nvSpPr>
+          <p:cNvPr id="9" name="TextBox 8"/>
+          <p:cNvSpPr txBox="1"/>
+          <p:nvPr/>
+        </p:nvSpPr>
+        <p:spPr>
+          <a:xfrm>
+            <a:off x="914400" y="5257800"/>
+            <a:ext cx="10058400" cy="365760"/>
+          </a:xfrm>
+          <a:prstGeom prst="rect">
+            <a:avLst/>
+          </a:prstGeom>
+          <a:noFill/>
+        </p:spPr>
+        <p:txBody>
+          <a:bodyPr wrap="square" anchor="t">
+            <a:spAutoFit/>
+          </a:bodyPr>
+          <a:lstStyle/>
+          <a:p>
+            <a:pPr algn="l"/>
+            <a:r>
+              <a:rPr sz="1100" b="0">
+                <a:solidFill>
+                  <a:srgbClr val="52667A"/>
+                </a:solidFill>
+                <a:latin typeface="Aptos"/>
+              </a:rPr>
+              <a:t>Related documents: docs/product-user-flows/08-doctor-verification-and-collateral-consumption.md, backend/sharing_management/views.py, backend/sharing_management/templates/sharing_management/fieldrep_gmail_share_collateral.html</a:t>
+            </a:r>
+          </a:p>
+        </p:txBody>
+      </p:sp>
+      <p:sp>
+        <p:nvSpPr>
+          <p:cNvPr id="10" name="TextBox 9"/>
+          <p:cNvSpPr txBox="1"/>
+          <p:nvPr/>
+        </p:nvSpPr>
+        <p:spPr>
+          <a:xfrm>
+            <a:off x="502920" y="6400800"/>
+            <a:ext cx="10972800" cy="182880"/>
+          </a:xfrm>
+          <a:prstGeom prst="rect">
+            <a:avLst/>
+          </a:prstGeom>
+          <a:noFill/>
+        </p:spPr>
+        <p:txBody>
+          <a:bodyPr wrap="square" anchor="t">
+            <a:spAutoFit/>
+          </a:bodyPr>
+          <a:lstStyle/>
+          <a:p>
+            <a:pPr algn="l"/>
+            <a:r>
+              <a:rPr sz="1000" b="0">
+                <a:solidFill>
+                  <a:srgbClr val="52667A"/>
+                </a:solidFill>
+                <a:latin typeface="Aptos"/>
+              </a:rPr>
+              <a:t>Validated against the Gmail/manual share flow and doctor bulk-upload page on 2026-04-23.</a:t>
+            </a:r>
+          </a:p>
+        </p:txBody>
+      </p:sp>
+    </p:spTree>
+  </p:cSld>
+  <p:clrMapOvr>
+    <a:masterClrMapping/>
+  </p:clrMapOvr>
+</p:sld>
+</file>
+
+<file path=ppt/slides/slide9.xml><?xml version="1.0" encoding="utf-8"?>
 <p:sld xmlns:a="http://schemas.openxmlformats.org/drawingml/2006/main" xmlns:p="http://schemas.openxmlformats.org/presentationml/2006/main" xmlns:r="http://schemas.openxmlformats.org/officeDocument/2006/relationships">
   <p:cSld>
     <p:bg>
@@ -7717,7 +7899,19 @@
                 </a:solidFill>
                 <a:latin typeface="Aptos"/>
               </a:rPr>
-              <a:t>The rep can explain how doctors and collateral are selected on the share page.</a:t>
+              <a:t>The rep can explain how the collateral selector, doctor search, and status filter work together on the share page.</a:t>
+            </a:r>
+          </a:p>
+          <a:p>
+            <a:pPr algn="l"/>
+            <a:r>
+              <a:rPr sz="2000">
+                <a:solidFill>
+                  <a:srgbClr val="FFFFFF"/>
+                </a:solidFill>
+                <a:latin typeface="Aptos"/>
+              </a:rPr>
+              <a:t>The audience understands the row-button lifecycle from `Send Message` to `Sent`, `Send Reminder`, and `Opened`.</a:t>
             </a:r>
           </a:p>
           <a:p>

</xml_diff>